<commit_message>
Add hyperlinks to slides final page
Co-Authored-By: Claude Opus 4.6 <noreply@anthropic.com>
</commit_message>
<xml_diff>
--- a/slides.pptx
+++ b/slides.pptx
@@ -6697,13 +6697,20 @@
               <a:buNone/>
             </a:pPr>
             <a:r>
-              <a:rPr lang="en-US" sz="1800" dirty="0">
+              <a:rPr lang="en-US" sz="1800" u="sng" dirty="0">
                 <a:solidFill>
                   <a:srgbClr val="FFFFFF"/>
                 </a:solidFill>
                 <a:latin typeface="Calibri" pitchFamily="34" charset="0"/>
                 <a:ea typeface="Calibri" pitchFamily="34" charset="-122"/>
                 <a:cs typeface="Calibri" pitchFamily="34" charset="-120"/>
+                <a:hlinkClick r:id="rId1" invalidUrl="" action="" tgtFrame="" tooltip="" history="1" highlightClick="0" endSnd="0">
+                  <a:extLst>
+                    <a:ext uri="{A12FA001-AC4F-418D-AE19-62706E023703}">
+                      <ahyp:hlinkClr xmlns:ahyp="http://schemas.microsoft.com/office/drawing/2018/hyperlinkcolor" val="tx"/>
+                    </a:ext>
+                  </a:extLst>
+                </a:hlinkClick>
               </a:rPr>
               <a:t>care-priority.streamlit.app</a:t>
             </a:r>
@@ -6746,13 +6753,20 @@
               <a:buNone/>
             </a:pPr>
             <a:r>
-              <a:rPr lang="en-US" sz="1800" dirty="0">
+              <a:rPr lang="en-US" sz="1800" u="sng" dirty="0">
                 <a:solidFill>
                   <a:srgbClr val="FFFFFF"/>
                 </a:solidFill>
                 <a:latin typeface="Calibri" pitchFamily="34" charset="0"/>
                 <a:ea typeface="Calibri" pitchFamily="34" charset="-122"/>
                 <a:cs typeface="Calibri" pitchFamily="34" charset="-120"/>
+                <a:hlinkClick r:id="rId2" invalidUrl="" action="" tgtFrame="" tooltip="" history="1" highlightClick="0" endSnd="0">
+                  <a:extLst>
+                    <a:ext uri="{A12FA001-AC4F-418D-AE19-62706E023703}">
+                      <ahyp:hlinkClr xmlns:ahyp="http://schemas.microsoft.com/office/drawing/2018/hyperlinkcolor" val="tx"/>
+                    </a:ext>
+                  </a:extLst>
+                </a:hlinkClick>
               </a:rPr>
               <a:t>github.com/rachel-wenhui-ma/care-priority</a:t>
             </a:r>

</xml_diff>

<commit_message>
Update slides: simplify scoring page, soften claims, add disclaimers
- Slide 5: reduce to 4 key risk factors for presentation clarity
- Slide 6: soften impact language (Est. avoidable), add planning estimate disclaimer
- Slide 4: soften linkage to "area-based linkage using patient geography"
- Slide 3: trim bottom note to two key extras

Co-Authored-By: Claude Opus 4.6 <noreply@anthropic.com>
</commit_message>
<xml_diff>
--- a/slides.pptx
+++ b/slides.pptx
@@ -2827,7 +2827,7 @@
               <a:buNone/>
             </a:pPr>
             <a:r>
-              <a:rPr lang="en-US" sz="1100" dirty="0">
+              <a:rPr lang="en-US" sz="1200" dirty="0">
                 <a:solidFill>
                   <a:srgbClr val="6B7B8D"/>
                 </a:solidFill>
@@ -2835,9 +2835,9 @@
                 <a:ea typeface="Calibri" pitchFamily="34" charset="-122"/>
                 <a:cs typeface="Calibri" pitchFamily="34" charset="-120"/>
               </a:rPr>
-              <a:t>+ AI-generated natural-language rationale per patient (Claude 3.5 Haiku)  ·  Full 78-community BC vulnerability ranking  ·  Opioid &amp; wait time context</a:t>
-            </a:r>
-            <a:endParaRPr lang="en-US" sz="1100" dirty="0"/>
+              <a:t>+ Claude AI per-patient rationale  ·  Full 78-community vulnerability ranking</a:t>
+            </a:r>
+            <a:endParaRPr lang="en-US" sz="1200" dirty="0"/>
           </a:p>
         </p:txBody>
       </p:sp>
@@ -3692,7 +3692,7 @@
                 <a:ea typeface="Calibri" pitchFamily="34" charset="-122"/>
                 <a:cs typeface="Calibri" pitchFamily="34" charset="-120"/>
               </a:rPr>
-              <a:t>Linkage: Patient postal code (FSA) → BC Community Health Service Area (CHSA)  —  CIHI area-based approach</a:t>
+              <a:t>Area-based linkage using patient geography to assign community context (CIHI-style approach)</a:t>
             </a:r>
             <a:endParaRPr lang="en-US" sz="1000" dirty="0"/>
           </a:p>
@@ -3802,7 +3802,7 @@
                 <a:ea typeface="Trebuchet MS" pitchFamily="34" charset="-122"/>
                 <a:cs typeface="Trebuchet MS" pitchFamily="34" charset="-120"/>
               </a:rPr>
-              <a:t>Patient Risk (7 components)</a:t>
+              <a:t>Patient Risk Score  (0–100)</a:t>
             </a:r>
             <a:endParaRPr lang="en-US" sz="1600" dirty="0"/>
           </a:p>
@@ -3834,7 +3834,7 @@
                 <a:gridCol w="2926080"/>
                 <a:gridCol w="914400"/>
               </a:tblGrid>
-              <a:tr h="301752">
+              <a:tr h="347472">
                 <a:tc>
                   <a:txBody>
                     <a:bodyPr/>
@@ -3844,7 +3844,7 @@
                         <a:buNone/>
                       </a:pPr>
                       <a:r>
-                        <a:rPr lang="en-US" sz="1200" dirty="0">
+                        <a:rPr lang="en-US" sz="1300" dirty="0">
                           <a:solidFill>
                             <a:srgbClr val="1B2A4A"/>
                           </a:solidFill>
@@ -3852,9 +3852,9 @@
                           <a:ea typeface="Calibri" pitchFamily="34" charset="-122"/>
                           <a:cs typeface="Calibri" pitchFamily="34" charset="-120"/>
                         </a:rPr>
-                        <a:t>ED visit frequency (12mo)</a:t>
+                        <a:t>Repeat ED visits (past 12 months)</a:t>
                       </a:r>
-                      <a:endParaRPr lang="en-US" sz="1200" dirty="0">
+                      <a:endParaRPr lang="en-US" sz="1300" dirty="0">
                         <a:latin typeface="Calibri" charset="0"/>
                         <a:ea typeface="Calibri" charset="0"/>
                         <a:cs typeface="Calibri" charset="0"/>
@@ -3888,7 +3888,7 @@
                         <a:buNone/>
                       </a:pPr>
                       <a:r>
-                        <a:rPr lang="en-US" sz="1200" b="1" dirty="0">
+                        <a:rPr lang="en-US" sz="1300" b="1" dirty="0">
                           <a:solidFill>
                             <a:srgbClr val="13547A"/>
                           </a:solidFill>
@@ -3898,7 +3898,7 @@
                         </a:rPr>
                         <a:t>25 pts</a:t>
                       </a:r>
-                      <a:endParaRPr lang="en-US" sz="1200" dirty="0">
+                      <a:endParaRPr lang="en-US" sz="1300" dirty="0">
                         <a:latin typeface="Calibri" charset="0"/>
                         <a:ea typeface="Calibri" charset="0"/>
                         <a:cs typeface="Calibri" charset="0"/>
@@ -3924,7 +3924,7 @@
                   </a:tcPr>
                 </a:tc>
               </a:tr>
-              <a:tr h="301752">
+              <a:tr h="347472">
                 <a:tc>
                   <a:txBody>
                     <a:bodyPr/>
@@ -3934,7 +3934,7 @@
                         <a:buNone/>
                       </a:pPr>
                       <a:r>
-                        <a:rPr lang="en-US" sz="1200" dirty="0">
+                        <a:rPr lang="en-US" sz="1300" dirty="0">
                           <a:solidFill>
                             <a:srgbClr val="1B2A4A"/>
                           </a:solidFill>
@@ -3942,9 +3942,9 @@
                           <a:ea typeface="Calibri" pitchFamily="34" charset="-122"/>
                           <a:cs typeface="Calibri" pitchFamily="34" charset="-120"/>
                         </a:rPr>
-                        <a:t>Chronic disease control</a:t>
+                        <a:t>Uncontrolled chronic disease (labs)</a:t>
                       </a:r>
-                      <a:endParaRPr lang="en-US" sz="1200" dirty="0">
+                      <a:endParaRPr lang="en-US" sz="1300" dirty="0">
                         <a:latin typeface="Calibri" charset="0"/>
                         <a:ea typeface="Calibri" charset="0"/>
                         <a:cs typeface="Calibri" charset="0"/>
@@ -3978,7 +3978,7 @@
                         <a:buNone/>
                       </a:pPr>
                       <a:r>
-                        <a:rPr lang="en-US" sz="1200" b="1" dirty="0">
+                        <a:rPr lang="en-US" sz="1300" b="1" dirty="0">
                           <a:solidFill>
                             <a:srgbClr val="13547A"/>
                           </a:solidFill>
@@ -3988,7 +3988,7 @@
                         </a:rPr>
                         <a:t>20 pts</a:t>
                       </a:r>
-                      <a:endParaRPr lang="en-US" sz="1200" dirty="0">
+                      <a:endParaRPr lang="en-US" sz="1300" dirty="0">
                         <a:latin typeface="Calibri" charset="0"/>
                         <a:ea typeface="Calibri" charset="0"/>
                         <a:cs typeface="Calibri" charset="0"/>
@@ -4014,7 +4014,7 @@
                   </a:tcPr>
                 </a:tc>
               </a:tr>
-              <a:tr h="301752">
+              <a:tr h="347472">
                 <a:tc>
                   <a:txBody>
                     <a:bodyPr/>
@@ -4024,7 +4024,7 @@
                         <a:buNone/>
                       </a:pPr>
                       <a:r>
-                        <a:rPr lang="en-US" sz="1200" dirty="0">
+                        <a:rPr lang="en-US" sz="1300" dirty="0">
                           <a:solidFill>
                             <a:srgbClr val="1B2A4A"/>
                           </a:solidFill>
@@ -4032,9 +4032,9 @@
                           <a:ea typeface="Calibri" pitchFamily="34" charset="-122"/>
                           <a:cs typeface="Calibri" pitchFamily="34" charset="-120"/>
                         </a:rPr>
-                        <a:t>Polypharmacy</a:t>
+                        <a:t>Polypharmacy (≥8 medications)</a:t>
                       </a:r>
-                      <a:endParaRPr lang="en-US" sz="1200" dirty="0">
+                      <a:endParaRPr lang="en-US" sz="1300" dirty="0">
                         <a:latin typeface="Calibri" charset="0"/>
                         <a:ea typeface="Calibri" charset="0"/>
                         <a:cs typeface="Calibri" charset="0"/>
@@ -4068,7 +4068,7 @@
                         <a:buNone/>
                       </a:pPr>
                       <a:r>
-                        <a:rPr lang="en-US" sz="1200" b="1" dirty="0">
+                        <a:rPr lang="en-US" sz="1300" b="1" dirty="0">
                           <a:solidFill>
                             <a:srgbClr val="13547A"/>
                           </a:solidFill>
@@ -4078,7 +4078,7 @@
                         </a:rPr>
                         <a:t>15 pts</a:t>
                       </a:r>
-                      <a:endParaRPr lang="en-US" sz="1200" dirty="0">
+                      <a:endParaRPr lang="en-US" sz="1300" dirty="0">
                         <a:latin typeface="Calibri" charset="0"/>
                         <a:ea typeface="Calibri" charset="0"/>
                         <a:cs typeface="Calibri" charset="0"/>
@@ -4104,7 +4104,7 @@
                   </a:tcPr>
                 </a:tc>
               </a:tr>
-              <a:tr h="301752">
+              <a:tr h="347472">
                 <a:tc>
                   <a:txBody>
                     <a:bodyPr/>
@@ -4114,7 +4114,7 @@
                         <a:buNone/>
                       </a:pPr>
                       <a:r>
-                        <a:rPr lang="en-US" sz="1200" dirty="0">
+                        <a:rPr lang="en-US" sz="1300" dirty="0">
                           <a:solidFill>
                             <a:srgbClr val="1B2A4A"/>
                           </a:solidFill>
@@ -4122,9 +4122,9 @@
                           <a:ea typeface="Calibri" pitchFamily="34" charset="-122"/>
                           <a:cs typeface="Calibri" pitchFamily="34" charset="-120"/>
                         </a:rPr>
-                        <a:t>Left-AMA history</a:t>
+                        <a:t>Left against medical advice</a:t>
                       </a:r>
-                      <a:endParaRPr lang="en-US" sz="1200" dirty="0">
+                      <a:endParaRPr lang="en-US" sz="1300" dirty="0">
                         <a:latin typeface="Calibri" charset="0"/>
                         <a:ea typeface="Calibri" charset="0"/>
                         <a:cs typeface="Calibri" charset="0"/>
@@ -4158,7 +4158,7 @@
                         <a:buNone/>
                       </a:pPr>
                       <a:r>
-                        <a:rPr lang="en-US" sz="1200" b="1" dirty="0">
+                        <a:rPr lang="en-US" sz="1300" b="1" dirty="0">
                           <a:solidFill>
                             <a:srgbClr val="13547A"/>
                           </a:solidFill>
@@ -4168,277 +4168,7 @@
                         </a:rPr>
                         <a:t>15 pts</a:t>
                       </a:r>
-                      <a:endParaRPr lang="en-US" sz="1200" dirty="0">
-                        <a:latin typeface="Calibri" charset="0"/>
-                        <a:ea typeface="Calibri" charset="0"/>
-                        <a:cs typeface="Calibri" charset="0"/>
-                      </a:endParaRPr>
-                    </a:p>
-                  </a:txBody>
-                  <a:tcPr marL="91440" marR="91440" marT="45720" marB="45720">
-                    <a:lnL w="0" cap="flat" cmpd="sng" algn="ctr">
-                      <a:noFill/>
-                    </a:lnL>
-                    <a:lnR w="0" cap="flat" cmpd="sng" algn="ctr">
-                      <a:noFill/>
-                    </a:lnR>
-                    <a:lnT w="0" cap="flat" cmpd="sng" algn="ctr">
-                      <a:noFill/>
-                    </a:lnT>
-                    <a:lnB w="0" cap="flat" cmpd="sng" algn="ctr">
-                      <a:noFill/>
-                    </a:lnB>
-                    <a:solidFill>
-                      <a:srgbClr val="FFFFFF"/>
-                    </a:solidFill>
-                  </a:tcPr>
-                </a:tc>
-              </a:tr>
-              <a:tr h="301752">
-                <a:tc>
-                  <a:txBody>
-                    <a:bodyPr/>
-                    <a:lstStyle/>
-                    <a:p>
-                      <a:pPr indent="0" marL="0">
-                        <a:buNone/>
-                      </a:pPr>
-                      <a:r>
-                        <a:rPr lang="en-US" sz="1200" dirty="0">
-                          <a:solidFill>
-                            <a:srgbClr val="1B2A4A"/>
-                          </a:solidFill>
-                          <a:latin typeface="Calibri" pitchFamily="34" charset="0"/>
-                          <a:ea typeface="Calibri" pitchFamily="34" charset="-122"/>
-                          <a:cs typeface="Calibri" pitchFamily="34" charset="-120"/>
-                        </a:rPr>
-                        <a:t>Post-discharge follow-up gap</a:t>
-                      </a:r>
-                      <a:endParaRPr lang="en-US" sz="1200" dirty="0">
-                        <a:latin typeface="Calibri" charset="0"/>
-                        <a:ea typeface="Calibri" charset="0"/>
-                        <a:cs typeface="Calibri" charset="0"/>
-                      </a:endParaRPr>
-                    </a:p>
-                  </a:txBody>
-                  <a:tcPr marL="91440" marR="91440" marT="45720" marB="45720">
-                    <a:lnL w="0" cap="flat" cmpd="sng" algn="ctr">
-                      <a:noFill/>
-                    </a:lnL>
-                    <a:lnR w="0" cap="flat" cmpd="sng" algn="ctr">
-                      <a:noFill/>
-                    </a:lnR>
-                    <a:lnT w="0" cap="flat" cmpd="sng" algn="ctr">
-                      <a:noFill/>
-                    </a:lnT>
-                    <a:lnB w="0" cap="flat" cmpd="sng" algn="ctr">
-                      <a:noFill/>
-                    </a:lnB>
-                    <a:solidFill>
-                      <a:srgbClr val="FFFFFF"/>
-                    </a:solidFill>
-                  </a:tcPr>
-                </a:tc>
-                <a:tc>
-                  <a:txBody>
-                    <a:bodyPr/>
-                    <a:lstStyle/>
-                    <a:p>
-                      <a:pPr algn="r" indent="0" marL="0">
-                        <a:buNone/>
-                      </a:pPr>
-                      <a:r>
-                        <a:rPr lang="en-US" sz="1200" b="1" dirty="0">
-                          <a:solidFill>
-                            <a:srgbClr val="13547A"/>
-                          </a:solidFill>
-                          <a:latin typeface="Calibri" pitchFamily="34" charset="0"/>
-                          <a:ea typeface="Calibri" pitchFamily="34" charset="-122"/>
-                          <a:cs typeface="Calibri" pitchFamily="34" charset="-120"/>
-                        </a:rPr>
-                        <a:t>10 pts</a:t>
-                      </a:r>
-                      <a:endParaRPr lang="en-US" sz="1200" dirty="0">
-                        <a:latin typeface="Calibri" charset="0"/>
-                        <a:ea typeface="Calibri" charset="0"/>
-                        <a:cs typeface="Calibri" charset="0"/>
-                      </a:endParaRPr>
-                    </a:p>
-                  </a:txBody>
-                  <a:tcPr marL="91440" marR="91440" marT="45720" marB="45720">
-                    <a:lnL w="0" cap="flat" cmpd="sng" algn="ctr">
-                      <a:noFill/>
-                    </a:lnL>
-                    <a:lnR w="0" cap="flat" cmpd="sng" algn="ctr">
-                      <a:noFill/>
-                    </a:lnR>
-                    <a:lnT w="0" cap="flat" cmpd="sng" algn="ctr">
-                      <a:noFill/>
-                    </a:lnT>
-                    <a:lnB w="0" cap="flat" cmpd="sng" algn="ctr">
-                      <a:noFill/>
-                    </a:lnB>
-                    <a:solidFill>
-                      <a:srgbClr val="FFFFFF"/>
-                    </a:solidFill>
-                  </a:tcPr>
-                </a:tc>
-              </a:tr>
-              <a:tr h="301752">
-                <a:tc>
-                  <a:txBody>
-                    <a:bodyPr/>
-                    <a:lstStyle/>
-                    <a:p>
-                      <a:pPr indent="0" marL="0">
-                        <a:buNone/>
-                      </a:pPr>
-                      <a:r>
-                        <a:rPr lang="en-US" sz="1200" dirty="0">
-                          <a:solidFill>
-                            <a:srgbClr val="1B2A4A"/>
-                          </a:solidFill>
-                          <a:latin typeface="Calibri" pitchFamily="34" charset="0"/>
-                          <a:ea typeface="Calibri" pitchFamily="34" charset="-122"/>
-                          <a:cs typeface="Calibri" pitchFamily="34" charset="-120"/>
-                        </a:rPr>
-                        <a:t>Wait time burden (Track 2)</a:t>
-                      </a:r>
-                      <a:endParaRPr lang="en-US" sz="1200" dirty="0">
-                        <a:latin typeface="Calibri" charset="0"/>
-                        <a:ea typeface="Calibri" charset="0"/>
-                        <a:cs typeface="Calibri" charset="0"/>
-                      </a:endParaRPr>
-                    </a:p>
-                  </a:txBody>
-                  <a:tcPr marL="91440" marR="91440" marT="45720" marB="45720">
-                    <a:lnL w="0" cap="flat" cmpd="sng" algn="ctr">
-                      <a:noFill/>
-                    </a:lnL>
-                    <a:lnR w="0" cap="flat" cmpd="sng" algn="ctr">
-                      <a:noFill/>
-                    </a:lnR>
-                    <a:lnT w="0" cap="flat" cmpd="sng" algn="ctr">
-                      <a:noFill/>
-                    </a:lnT>
-                    <a:lnB w="0" cap="flat" cmpd="sng" algn="ctr">
-                      <a:noFill/>
-                    </a:lnB>
-                    <a:solidFill>
-                      <a:srgbClr val="FFFFFF"/>
-                    </a:solidFill>
-                  </a:tcPr>
-                </a:tc>
-                <a:tc>
-                  <a:txBody>
-                    <a:bodyPr/>
-                    <a:lstStyle/>
-                    <a:p>
-                      <a:pPr algn="r" indent="0" marL="0">
-                        <a:buNone/>
-                      </a:pPr>
-                      <a:r>
-                        <a:rPr lang="en-US" sz="1200" b="1" dirty="0">
-                          <a:solidFill>
-                            <a:srgbClr val="13547A"/>
-                          </a:solidFill>
-                          <a:latin typeface="Calibri" pitchFamily="34" charset="0"/>
-                          <a:ea typeface="Calibri" pitchFamily="34" charset="-122"/>
-                          <a:cs typeface="Calibri" pitchFamily="34" charset="-120"/>
-                        </a:rPr>
-                        <a:t>10 pts</a:t>
-                      </a:r>
-                      <a:endParaRPr lang="en-US" sz="1200" dirty="0">
-                        <a:latin typeface="Calibri" charset="0"/>
-                        <a:ea typeface="Calibri" charset="0"/>
-                        <a:cs typeface="Calibri" charset="0"/>
-                      </a:endParaRPr>
-                    </a:p>
-                  </a:txBody>
-                  <a:tcPr marL="91440" marR="91440" marT="45720" marB="45720">
-                    <a:lnL w="0" cap="flat" cmpd="sng" algn="ctr">
-                      <a:noFill/>
-                    </a:lnL>
-                    <a:lnR w="0" cap="flat" cmpd="sng" algn="ctr">
-                      <a:noFill/>
-                    </a:lnR>
-                    <a:lnT w="0" cap="flat" cmpd="sng" algn="ctr">
-                      <a:noFill/>
-                    </a:lnT>
-                    <a:lnB w="0" cap="flat" cmpd="sng" algn="ctr">
-                      <a:noFill/>
-                    </a:lnB>
-                    <a:solidFill>
-                      <a:srgbClr val="FFFFFF"/>
-                    </a:solidFill>
-                  </a:tcPr>
-                </a:tc>
-              </a:tr>
-              <a:tr h="301752">
-                <a:tc>
-                  <a:txBody>
-                    <a:bodyPr/>
-                    <a:lstStyle/>
-                    <a:p>
-                      <a:pPr indent="0" marL="0">
-                        <a:buNone/>
-                      </a:pPr>
-                      <a:r>
-                        <a:rPr lang="en-US" sz="1200" dirty="0">
-                          <a:solidFill>
-                            <a:srgbClr val="1B2A4A"/>
-                          </a:solidFill>
-                          <a:latin typeface="Calibri" pitchFamily="34" charset="0"/>
-                          <a:ea typeface="Calibri" pitchFamily="34" charset="-122"/>
-                          <a:cs typeface="Calibri" pitchFamily="34" charset="-120"/>
-                        </a:rPr>
-                        <a:t>Language barrier</a:t>
-                      </a:r>
-                      <a:endParaRPr lang="en-US" sz="1200" dirty="0">
-                        <a:latin typeface="Calibri" charset="0"/>
-                        <a:ea typeface="Calibri" charset="0"/>
-                        <a:cs typeface="Calibri" charset="0"/>
-                      </a:endParaRPr>
-                    </a:p>
-                  </a:txBody>
-                  <a:tcPr marL="91440" marR="91440" marT="45720" marB="45720">
-                    <a:lnL w="0" cap="flat" cmpd="sng" algn="ctr">
-                      <a:noFill/>
-                    </a:lnL>
-                    <a:lnR w="0" cap="flat" cmpd="sng" algn="ctr">
-                      <a:noFill/>
-                    </a:lnR>
-                    <a:lnT w="0" cap="flat" cmpd="sng" algn="ctr">
-                      <a:noFill/>
-                    </a:lnT>
-                    <a:lnB w="0" cap="flat" cmpd="sng" algn="ctr">
-                      <a:noFill/>
-                    </a:lnB>
-                    <a:solidFill>
-                      <a:srgbClr val="FFFFFF"/>
-                    </a:solidFill>
-                  </a:tcPr>
-                </a:tc>
-                <a:tc>
-                  <a:txBody>
-                    <a:bodyPr/>
-                    <a:lstStyle/>
-                    <a:p>
-                      <a:pPr algn="r" indent="0" marL="0">
-                        <a:buNone/>
-                      </a:pPr>
-                      <a:r>
-                        <a:rPr lang="en-US" sz="1200" b="1" dirty="0">
-                          <a:solidFill>
-                            <a:srgbClr val="13547A"/>
-                          </a:solidFill>
-                          <a:latin typeface="Calibri" pitchFamily="34" charset="0"/>
-                          <a:ea typeface="Calibri" pitchFamily="34" charset="-122"/>
-                          <a:cs typeface="Calibri" pitchFamily="34" charset="-120"/>
-                        </a:rPr>
-                        <a:t>5 pts</a:t>
-                      </a:r>
-                      <a:endParaRPr lang="en-US" sz="1200" dirty="0">
+                      <a:endParaRPr lang="en-US" sz="1300" dirty="0">
                         <a:latin typeface="Calibri" charset="0"/>
                         <a:ea typeface="Calibri" charset="0"/>
                         <a:cs typeface="Calibri" charset="0"/>
@@ -4476,6 +4206,45 @@
         </p:nvSpPr>
         <p:spPr>
           <a:xfrm>
+            <a:off x="731520" y="2971800"/>
+            <a:ext cx="3840480" cy="365760"/>
+          </a:xfrm>
+          <a:prstGeom prst="rect">
+            <a:avLst/>
+          </a:prstGeom>
+          <a:noFill/>
+          <a:ln/>
+        </p:spPr>
+        <p:txBody>
+          <a:bodyPr wrap="square" lIns="0" tIns="0" rIns="0" bIns="0" rtlCol="0" anchor="ctr"/>
+          <a:lstStyle/>
+          <a:p>
+            <a:pPr indent="0" marL="0">
+              <a:buNone/>
+            </a:pPr>
+            <a:r>
+              <a:rPr lang="en-US" sz="1100" i="1" dirty="0">
+                <a:solidFill>
+                  <a:srgbClr val="6B7B8D"/>
+                </a:solidFill>
+                <a:latin typeface="Calibri" pitchFamily="34" charset="0"/>
+                <a:ea typeface="Calibri" pitchFamily="34" charset="-122"/>
+                <a:cs typeface="Calibri" pitchFamily="34" charset="-120"/>
+              </a:rPr>
+              <a:t>+ 3 additional factors (follow-up gap, wait burden, language barrier). All weights auditable in config.py.</a:t>
+            </a:r>
+            <a:endParaRPr lang="en-US" sz="1100" dirty="0"/>
+          </a:p>
+        </p:txBody>
+      </p:sp>
+      <p:sp>
+        <p:nvSpPr>
+          <p:cNvPr id="6" name="Text 3"/>
+          <p:cNvSpPr/>
+          <p:nvPr/>
+        </p:nvSpPr>
+        <p:spPr>
+          <a:xfrm>
             <a:off x="5029200" y="1051560"/>
             <a:ext cx="3657600" cy="365760"/>
           </a:xfrm>
@@ -4509,7 +4278,7 @@
       </p:sp>
       <p:sp>
         <p:nvSpPr>
-          <p:cNvPr id="6" name="Shape 3"/>
+          <p:cNvPr id="7" name="Shape 4"/>
           <p:cNvSpPr/>
           <p:nvPr/>
         </p:nvSpPr>
@@ -4536,7 +4305,7 @@
       </p:sp>
       <p:sp>
         <p:nvSpPr>
-          <p:cNvPr id="7" name="Shape 4"/>
+          <p:cNvPr id="8" name="Shape 5"/>
           <p:cNvSpPr/>
           <p:nvPr/>
         </p:nvSpPr>
@@ -4556,7 +4325,7 @@
       </p:sp>
       <p:sp>
         <p:nvSpPr>
-          <p:cNvPr id="8" name="Text 5"/>
+          <p:cNvPr id="9" name="Text 6"/>
           <p:cNvSpPr/>
           <p:nvPr/>
         </p:nvSpPr>
@@ -4595,7 +4364,7 @@
       </p:sp>
       <p:sp>
         <p:nvSpPr>
-          <p:cNvPr id="9" name="Text 6"/>
+          <p:cNvPr id="10" name="Text 7"/>
           <p:cNvSpPr/>
           <p:nvPr/>
         </p:nvSpPr>
@@ -4634,7 +4403,7 @@
       </p:sp>
       <p:sp>
         <p:nvSpPr>
-          <p:cNvPr id="10" name="Text 7"/>
+          <p:cNvPr id="11" name="Text 8"/>
           <p:cNvSpPr/>
           <p:nvPr/>
         </p:nvSpPr>
@@ -4673,7 +4442,7 @@
       </p:sp>
       <p:sp>
         <p:nvSpPr>
-          <p:cNvPr id="11" name="Shape 8"/>
+          <p:cNvPr id="12" name="Shape 9"/>
           <p:cNvSpPr/>
           <p:nvPr/>
         </p:nvSpPr>
@@ -4700,7 +4469,7 @@
       </p:sp>
       <p:sp>
         <p:nvSpPr>
-          <p:cNvPr id="12" name="Shape 9"/>
+          <p:cNvPr id="13" name="Shape 10"/>
           <p:cNvSpPr/>
           <p:nvPr/>
         </p:nvSpPr>
@@ -4720,7 +4489,7 @@
       </p:sp>
       <p:sp>
         <p:nvSpPr>
-          <p:cNvPr id="13" name="Text 10"/>
+          <p:cNvPr id="14" name="Text 11"/>
           <p:cNvSpPr/>
           <p:nvPr/>
         </p:nvSpPr>
@@ -4759,7 +4528,7 @@
       </p:sp>
       <p:sp>
         <p:nvSpPr>
-          <p:cNvPr id="14" name="Text 11"/>
+          <p:cNvPr id="15" name="Text 12"/>
           <p:cNvSpPr/>
           <p:nvPr/>
         </p:nvSpPr>
@@ -4798,7 +4567,7 @@
       </p:sp>
       <p:sp>
         <p:nvSpPr>
-          <p:cNvPr id="15" name="Text 12"/>
+          <p:cNvPr id="16" name="Text 13"/>
           <p:cNvSpPr/>
           <p:nvPr/>
         </p:nvSpPr>
@@ -4837,7 +4606,7 @@
       </p:sp>
       <p:sp>
         <p:nvSpPr>
-          <p:cNvPr id="16" name="Shape 13"/>
+          <p:cNvPr id="17" name="Shape 14"/>
           <p:cNvSpPr/>
           <p:nvPr/>
         </p:nvSpPr>
@@ -4864,7 +4633,7 @@
       </p:sp>
       <p:sp>
         <p:nvSpPr>
-          <p:cNvPr id="17" name="Shape 14"/>
+          <p:cNvPr id="18" name="Shape 15"/>
           <p:cNvSpPr/>
           <p:nvPr/>
         </p:nvSpPr>
@@ -4884,7 +4653,7 @@
       </p:sp>
       <p:sp>
         <p:nvSpPr>
-          <p:cNvPr id="18" name="Text 15"/>
+          <p:cNvPr id="19" name="Text 16"/>
           <p:cNvSpPr/>
           <p:nvPr/>
         </p:nvSpPr>
@@ -4923,7 +4692,7 @@
       </p:sp>
       <p:sp>
         <p:nvSpPr>
-          <p:cNvPr id="19" name="Text 16"/>
+          <p:cNvPr id="20" name="Text 17"/>
           <p:cNvSpPr/>
           <p:nvPr/>
         </p:nvSpPr>
@@ -4962,7 +4731,7 @@
       </p:sp>
       <p:sp>
         <p:nvSpPr>
-          <p:cNvPr id="20" name="Text 17"/>
+          <p:cNvPr id="21" name="Text 18"/>
           <p:cNvSpPr/>
           <p:nvPr/>
         </p:nvSpPr>
@@ -5001,7 +4770,7 @@
       </p:sp>
       <p:sp>
         <p:nvSpPr>
-          <p:cNvPr id="21" name="Shape 18"/>
+          <p:cNvPr id="22" name="Shape 19"/>
           <p:cNvSpPr/>
           <p:nvPr/>
         </p:nvSpPr>
@@ -5028,7 +4797,7 @@
       </p:sp>
       <p:sp>
         <p:nvSpPr>
-          <p:cNvPr id="22" name="Shape 19"/>
+          <p:cNvPr id="23" name="Shape 20"/>
           <p:cNvSpPr/>
           <p:nvPr/>
         </p:nvSpPr>
@@ -5048,7 +4817,7 @@
       </p:sp>
       <p:sp>
         <p:nvSpPr>
-          <p:cNvPr id="23" name="Text 20"/>
+          <p:cNvPr id="24" name="Text 21"/>
           <p:cNvSpPr/>
           <p:nvPr/>
         </p:nvSpPr>
@@ -5087,7 +4856,7 @@
       </p:sp>
       <p:sp>
         <p:nvSpPr>
-          <p:cNvPr id="24" name="Text 21"/>
+          <p:cNvPr id="25" name="Text 22"/>
           <p:cNvSpPr/>
           <p:nvPr/>
         </p:nvSpPr>
@@ -5126,7 +4895,7 @@
       </p:sp>
       <p:sp>
         <p:nvSpPr>
-          <p:cNvPr id="25" name="Text 22"/>
+          <p:cNvPr id="26" name="Text 23"/>
           <p:cNvSpPr/>
           <p:nvPr/>
         </p:nvSpPr>
@@ -5165,7 +4934,7 @@
       </p:sp>
       <p:sp>
         <p:nvSpPr>
-          <p:cNvPr id="26" name="Text 23"/>
+          <p:cNvPr id="27" name="Text 24"/>
           <p:cNvSpPr/>
           <p:nvPr/>
         </p:nvSpPr>
@@ -5676,7 +5445,7 @@
                 <a:ea typeface="Calibri" pitchFamily="34" charset="-122"/>
                 <a:cs typeface="Calibri" pitchFamily="34" charset="-120"/>
               </a:rPr>
-              <a:t>Preventable ED</a:t>
+              <a:t>Est. avoidable ED</a:t>
             </a:r>
             <a:endParaRPr lang="en-US" sz="1200" dirty="0"/>
           </a:p>
@@ -5818,7 +5587,7 @@
                 <a:ea typeface="Calibri" pitchFamily="34" charset="-122"/>
                 <a:cs typeface="Calibri" pitchFamily="34" charset="-120"/>
               </a:rPr>
-              <a:t>Potential annual</a:t>
+              <a:t>Est. annual</a:t>
             </a:r>
             <a:endParaRPr lang="en-US" sz="1200" dirty="0"/>
           </a:p>
@@ -5889,7 +5658,7 @@
         <p:spPr>
           <a:xfrm>
             <a:off x="731520" y="3611880"/>
-            <a:ext cx="7680960" cy="1371600"/>
+            <a:ext cx="7680960" cy="1188720"/>
           </a:xfrm>
           <a:prstGeom prst="rect">
             <a:avLst/>
@@ -5933,7 +5702,7 @@
                 <a:ea typeface="Calibri" pitchFamily="34" charset="-122"/>
                 <a:cs typeface="Calibri" pitchFamily="34" charset="-120"/>
               </a:rPr>
-              <a:t>Outreaching just 50 patients avoids 96 ED visits/yr ($48K savings)</a:t>
+              <a:t>Outreaching top 50 patients → est. 96 fewer ED visits/yr</a:t>
             </a:r>
             <a:endParaRPr lang="en-US" sz="1400" dirty="0"/>
           </a:p>
@@ -5970,7 +5739,7 @@
                 <a:ea typeface="Calibri" pitchFamily="34" charset="-122"/>
                 <a:cs typeface="Calibri" pitchFamily="34" charset="-120"/>
               </a:rPr>
-              <a:t>5pp improvement in GP attachment shifts 547 patients to lower-urgency tiers</a:t>
+              <a:t>5pp GP attachment improvement → 547 patients shift to lower-urgency tiers</a:t>
             </a:r>
             <a:endParaRPr lang="en-US" sz="1400" dirty="0"/>
           </a:p>
@@ -6010,6 +5779,45 @@
               <a:t>Each patient has structured reasoning — Clinical Need, Access Barrier, System Impact</a:t>
             </a:r>
             <a:endParaRPr lang="en-US" sz="1400" dirty="0"/>
+          </a:p>
+        </p:txBody>
+      </p:sp>
+      <p:sp>
+        <p:nvSpPr>
+          <p:cNvPr id="21" name="Text 19"/>
+          <p:cNvSpPr/>
+          <p:nvPr/>
+        </p:nvSpPr>
+        <p:spPr>
+          <a:xfrm>
+            <a:off x="731520" y="4663440"/>
+            <a:ext cx="7680960" cy="274320"/>
+          </a:xfrm>
+          <a:prstGeom prst="rect">
+            <a:avLst/>
+          </a:prstGeom>
+          <a:noFill/>
+          <a:ln/>
+        </p:spPr>
+        <p:txBody>
+          <a:bodyPr wrap="square" lIns="0" tIns="0" rIns="0" bIns="0" rtlCol="0" anchor="ctr"/>
+          <a:lstStyle/>
+          <a:p>
+            <a:pPr indent="0" marL="0">
+              <a:buNone/>
+            </a:pPr>
+            <a:r>
+              <a:rPr lang="en-US" sz="1000" i="1" dirty="0">
+                <a:solidFill>
+                  <a:srgbClr val="6B7B8D"/>
+                </a:solidFill>
+                <a:latin typeface="Calibri" pitchFamily="34" charset="0"/>
+                <a:ea typeface="Calibri" pitchFamily="34" charset="-122"/>
+                <a:cs typeface="Calibri" pitchFamily="34" charset="-120"/>
+              </a:rPr>
+              <a:t>All impact figures are scenario-based planning estimates, not validated causal outcomes.</a:t>
+            </a:r>
+            <a:endParaRPr lang="en-US" sz="1000" dirty="0"/>
           </a:p>
         </p:txBody>
       </p:sp>

</xml_diff>

<commit_message>
Update slides with speaker notes
Co-Authored-By: Claude Opus 4.6 <noreply@anthropic.com>
</commit_message>
<xml_diff>
--- a/slides.pptx
+++ b/slides.pptx
@@ -4,6 +4,9 @@
   <p:sldMasterIdLst>
     <p:sldMasterId id="2147483648" r:id="rId1"/>
   </p:sldMasterIdLst>
+  <p:notesMasterIdLst>
+    <p:notesMasterId r:id="rId10"/>
+  </p:notesMasterIdLst>
   <p:sldIdLst>
     <p:sldId id="256" r:id="rId2"/>
     <p:sldId id="257" r:id="rId3"/>
@@ -14,10 +17,7 @@
     <p:sldId id="262" r:id="rId8"/>
     <p:sldId id="263" r:id="rId9"/>
   </p:sldIdLst>
-  <p:notesMasterIdLst>
-    <p:notesMasterId r:id="rId10"/>
-  </p:notesMasterIdLst>
-  <p:sldSz cx="9144000" cy="5143500"/>
+  <p:sldSz cx="9144000" cy="5143500" type="screen16x9"/>
   <p:notesSz cx="5143500" cy="9144000"/>
   <p:defaultTextStyle>
     <a:lvl1pPr marL="0" algn="l" defTabSz="914400" rtl="0" eaLnBrk="1" latinLnBrk="0" hangingPunct="1">
@@ -111,6 +111,11 @@
       </a:defRPr>
     </a:lvl9pPr>
   </p:defaultTextStyle>
+  <p:extLst>
+    <p:ext uri="{EFAFB233-063F-42B5-8137-9DF3F51BA10A}">
+      <p15:sldGuideLst xmlns:p15="http://schemas.microsoft.com/office/powerpoint/2012/main"/>
+    </p:ext>
+  </p:extLst>
 </p:presentation>
 </file>
 
@@ -136,234 +141,10 @@
           <a:chExt cx="0" cy="0"/>
         </a:xfrm>
       </p:grpSpPr>
-      <p:sp>
-        <p:nvSpPr>
-          <p:cNvPr id="2" name="Header Placeholder 1"/>
-          <p:cNvSpPr>
-            <a:spLocks noGrp="1"/>
-          </p:cNvSpPr>
-          <p:nvPr>
-            <p:ph type="hdr" sz="quarter"/>
-          </p:nvPr>
-        </p:nvSpPr>
-        <p:spPr>
-          <a:xfrm>
-            <a:off x="0" y="0"/>
-            <a:ext cx="2971800" cy="458788"/>
-          </a:xfrm>
-          <a:prstGeom prst="rect">
-            <a:avLst/>
-          </a:prstGeom>
-        </p:spPr>
-        <p:txBody>
-          <a:bodyPr vert="horz" lIns="91440" tIns="45720" rIns="91440" bIns="45720" rtlCol="0"/>
-          <a:lstStyle>
-            <a:lvl1pPr algn="l">
-              <a:defRPr sz="1200"/>
-            </a:lvl1pPr>
-          </a:lstStyle>
-          <a:p>
-            <a:endParaRPr lang="en-US"/>
-          </a:p>
-        </p:txBody>
-      </p:sp>
-      <p:sp>
-        <p:nvSpPr>
-          <p:cNvPr id="3" name="Date Placeholder 2"/>
-          <p:cNvSpPr>
-            <a:spLocks noGrp="1"/>
-          </p:cNvSpPr>
-          <p:nvPr>
-            <p:ph type="dt" idx="1"/>
-          </p:nvPr>
-        </p:nvSpPr>
-        <p:spPr>
-          <a:xfrm>
-            <a:off x="3884613" y="0"/>
-            <a:ext cx="2971800" cy="458788"/>
-          </a:xfrm>
-          <a:prstGeom prst="rect">
-            <a:avLst/>
-          </a:prstGeom>
-        </p:spPr>
-        <p:txBody>
-          <a:bodyPr vert="horz" lIns="91440" tIns="45720" rIns="91440" bIns="45720" rtlCol="0"/>
-          <a:lstStyle>
-            <a:lvl1pPr algn="r">
-              <a:defRPr sz="1200"/>
-            </a:lvl1pPr>
-          </a:lstStyle>
-          <a:p>
-            <a:fld id="{5282F153-3F37-0F45-9E97-73ACFA13230C}" type="datetimeFigureOut">
-              <a:rPr lang="en-US"/>
-              <a:t>7/23/19</a:t>
-            </a:fld>
-            <a:endParaRPr lang="en-US"/>
-          </a:p>
-        </p:txBody>
-      </p:sp>
-      <p:sp>
-        <p:nvSpPr>
-          <p:cNvPr id="4" name="Slide Image Placeholder 3"/>
-          <p:cNvSpPr>
-            <a:spLocks noGrp="1" noRot="1" noChangeAspect="1"/>
-          </p:cNvSpPr>
-          <p:nvPr>
-            <p:ph type="sldImg" idx="2"/>
-          </p:nvPr>
-        </p:nvSpPr>
-        <p:spPr>
-          <a:xfrm>
-            <a:off x="685800" y="1143000"/>
-            <a:ext cx="5486400" cy="3086100"/>
-          </a:xfrm>
-          <a:prstGeom prst="rect">
-            <a:avLst/>
-          </a:prstGeom>
-          <a:noFill/>
-          <a:ln w="12700">
-            <a:solidFill>
-              <a:prstClr val="black"/>
-            </a:solidFill>
-          </a:ln>
-        </p:spPr>
-        <p:txBody>
-          <a:bodyPr vert="horz" lIns="91440" tIns="45720" rIns="91440" bIns="45720" rtlCol="0" anchor="ctr"/>
-          <a:lstStyle/>
-          <a:p>
-            <a:endParaRPr lang="en-US"/>
-          </a:p>
-        </p:txBody>
-      </p:sp>
-      <p:sp>
-        <p:nvSpPr>
-          <p:cNvPr id="5" name="Notes Placeholder 4"/>
-          <p:cNvSpPr>
-            <a:spLocks noGrp="1"/>
-          </p:cNvSpPr>
-          <p:nvPr>
-            <p:ph type="body" sz="quarter" idx="3"/>
-          </p:nvPr>
-        </p:nvSpPr>
-        <p:spPr>
-          <a:xfrm>
-            <a:off x="685800" y="4400550"/>
-            <a:ext cx="5486400" cy="3600450"/>
-          </a:xfrm>
-          <a:prstGeom prst="rect">
-            <a:avLst/>
-          </a:prstGeom>
-        </p:spPr>
-        <p:txBody>
-          <a:bodyPr vert="horz" lIns="91440" tIns="45720" rIns="91440" bIns="45720" rtlCol="0"/>
-          <a:lstStyle/>
-          <a:p>
-            <a:pPr lvl="0"/>
-            <a:r>
-              <a:rPr lang="en-US"/>
-              <a:t>Click to edit Master text styles</a:t>
-            </a:r>
-          </a:p>
-          <a:p>
-            <a:pPr lvl="1"/>
-            <a:r>
-              <a:rPr lang="en-US"/>
-              <a:t>Second level</a:t>
-            </a:r>
-          </a:p>
-          <a:p>
-            <a:pPr lvl="2"/>
-            <a:r>
-              <a:rPr lang="en-US"/>
-              <a:t>Third level</a:t>
-            </a:r>
-          </a:p>
-          <a:p>
-            <a:pPr lvl="3"/>
-            <a:r>
-              <a:rPr lang="en-US"/>
-              <a:t>Fourth level</a:t>
-            </a:r>
-          </a:p>
-          <a:p>
-            <a:pPr lvl="4"/>
-            <a:r>
-              <a:rPr lang="en-US"/>
-              <a:t>Fifth level</a:t>
-            </a:r>
-          </a:p>
-        </p:txBody>
-      </p:sp>
-      <p:sp>
-        <p:nvSpPr>
-          <p:cNvPr id="6" name="Footer Placeholder 5"/>
-          <p:cNvSpPr>
-            <a:spLocks noGrp="1"/>
-          </p:cNvSpPr>
-          <p:nvPr>
-            <p:ph type="ftr" sz="quarter" idx="4"/>
-          </p:nvPr>
-        </p:nvSpPr>
-        <p:spPr>
-          <a:xfrm>
-            <a:off x="0" y="8685213"/>
-            <a:ext cx="2971800" cy="458787"/>
-          </a:xfrm>
-          <a:prstGeom prst="rect">
-            <a:avLst/>
-          </a:prstGeom>
-        </p:spPr>
-        <p:txBody>
-          <a:bodyPr vert="horz" lIns="91440" tIns="45720" rIns="91440" bIns="45720" rtlCol="0" anchor="b"/>
-          <a:lstStyle>
-            <a:lvl1pPr algn="l">
-              <a:defRPr sz="1200"/>
-            </a:lvl1pPr>
-          </a:lstStyle>
-          <a:p>
-            <a:endParaRPr lang="en-US"/>
-          </a:p>
-        </p:txBody>
-      </p:sp>
-      <p:sp>
-        <p:nvSpPr>
-          <p:cNvPr id="7" name="Slide Number Placeholder 6"/>
-          <p:cNvSpPr>
-            <a:spLocks noGrp="1"/>
-          </p:cNvSpPr>
-          <p:nvPr>
-            <p:ph type="sldNum" sz="quarter" idx="5"/>
-          </p:nvPr>
-        </p:nvSpPr>
-        <p:spPr>
-          <a:xfrm>
-            <a:off x="3884613" y="8685213"/>
-            <a:ext cx="2971800" cy="458787"/>
-          </a:xfrm>
-          <a:prstGeom prst="rect">
-            <a:avLst/>
-          </a:prstGeom>
-        </p:spPr>
-        <p:txBody>
-          <a:bodyPr vert="horz" lIns="91440" tIns="45720" rIns="91440" bIns="45720" rtlCol="0" anchor="b"/>
-          <a:lstStyle>
-            <a:lvl1pPr algn="r">
-              <a:defRPr sz="1200"/>
-            </a:lvl1pPr>
-          </a:lstStyle>
-          <a:p>
-            <a:fld id="{CE5E9CC1-C706-0F49-92D6-E571CC5EEA8F}" type="slidenum">
-              <a:rPr lang="en-US"/>
-              <a:t>‹#›</a:t>
-            </a:fld>
-            <a:endParaRPr lang="en-US"/>
-          </a:p>
-        </p:txBody>
-      </p:sp>
     </p:spTree>
     <p:extLst>
       <p:ext uri="{BB962C8B-B14F-4D97-AF65-F5344CB8AC3E}">
-        <p14:creationId xmlns:p14="http://schemas.microsoft.com/office/powerpoint/2010/main" val="1024086991"/>
+        <p14:creationId xmlns:p14="http://schemas.microsoft.com/office/powerpoint/2010/main" val="721832323"/>
       </p:ext>
     </p:extLst>
   </p:cSld>
@@ -508,9 +289,45 @@
           <a:lstStyle/>
           <a:p>
             <a:r>
-              <a:rPr lang="en-US" dirty="0"/>
-              <a:t/>
-            </a:r>
+              <a:rPr lang="en-US" altLang="zh-CN" dirty="0"/>
+              <a:t>Hello everyone.</a:t>
+            </a:r>
+            <a:br>
+              <a:rPr lang="en-US" altLang="zh-CN" dirty="0"/>
+            </a:br>
+            <a:r>
+              <a:rPr lang="en-US" altLang="zh-CN" dirty="0"/>
+              <a:t>We are Rachel and Joel.</a:t>
+            </a:r>
+          </a:p>
+          <a:p>
+            <a:r>
+              <a:rPr lang="en-US" altLang="zh-CN" dirty="0"/>
+              <a:t>Our project is called </a:t>
+            </a:r>
+            <a:r>
+              <a:rPr lang="en-US" altLang="zh-CN" b="1" dirty="0"/>
+              <a:t>AI-Enabled Care Prioritization System</a:t>
+            </a:r>
+            <a:r>
+              <a:rPr lang="en-US" altLang="zh-CN" dirty="0"/>
+              <a:t>.</a:t>
+            </a:r>
+          </a:p>
+          <a:p>
+            <a:r>
+              <a:rPr lang="en-US" altLang="zh-CN" dirty="0"/>
+              <a:t>It starts with one simple question:</a:t>
+            </a:r>
+          </a:p>
+          <a:p>
+            <a:r>
+              <a:rPr lang="en-US" altLang="zh-CN" b="1" dirty="0"/>
+              <a:t>When care resources are limited, who should we help first?</a:t>
+            </a:r>
+            <a:endParaRPr lang="en-US" altLang="zh-CN" dirty="0"/>
+          </a:p>
+          <a:p>
             <a:endParaRPr lang="en-US" dirty="0"/>
           </a:p>
         </p:txBody>
@@ -596,9 +413,73 @@
           <a:lstStyle/>
           <a:p>
             <a:r>
-              <a:rPr lang="en-US" dirty="0"/>
-              <a:t/>
-            </a:r>
+              <a:rPr lang="en-US" altLang="zh-CN" dirty="0"/>
+              <a:t>In BC, many people still do not have a family doctor.</a:t>
+            </a:r>
+            <a:br>
+              <a:rPr lang="en-US" altLang="zh-CN" dirty="0"/>
+            </a:br>
+            <a:r>
+              <a:rPr lang="en-US" altLang="zh-CN" dirty="0"/>
+              <a:t>Because of that, some patients keep returning to the emergency department, not only because of clinical need, but also because they live in communities with weaker access to care.</a:t>
+            </a:r>
+          </a:p>
+          <a:p>
+            <a:r>
+              <a:rPr lang="en-US" altLang="zh-CN" dirty="0"/>
+              <a:t>That is the gap we wanted to address.</a:t>
+            </a:r>
+          </a:p>
+          <a:p>
+            <a:r>
+              <a:rPr lang="en-US" altLang="zh-CN" dirty="0"/>
+              <a:t>Most existing tools look at only one side.</a:t>
+            </a:r>
+            <a:br>
+              <a:rPr lang="en-US" altLang="zh-CN" dirty="0"/>
+            </a:br>
+            <a:r>
+              <a:rPr lang="en-US" altLang="zh-CN" dirty="0"/>
+              <a:t>They look at clinical data, or they look at community data.</a:t>
+            </a:r>
+            <a:br>
+              <a:rPr lang="en-US" altLang="zh-CN" dirty="0"/>
+            </a:br>
+            <a:r>
+              <a:rPr lang="en-US" altLang="zh-CN" dirty="0"/>
+              <a:t>But in real life, both matter.</a:t>
+            </a:r>
+          </a:p>
+          <a:p>
+            <a:r>
+              <a:rPr lang="en-US" altLang="zh-CN" dirty="0"/>
+              <a:t>So our idea was simple:</a:t>
+            </a:r>
+            <a:br>
+              <a:rPr lang="en-US" altLang="zh-CN" dirty="0"/>
+            </a:br>
+            <a:r>
+              <a:rPr lang="en-US" altLang="zh-CN" dirty="0"/>
+              <a:t>combine </a:t>
+            </a:r>
+            <a:r>
+              <a:rPr lang="en-US" altLang="zh-CN" b="1" dirty="0"/>
+              <a:t>patient clinical risk</a:t>
+            </a:r>
+            <a:r>
+              <a:rPr lang="en-US" altLang="zh-CN" dirty="0"/>
+              <a:t> with </a:t>
+            </a:r>
+            <a:r>
+              <a:rPr lang="en-US" altLang="zh-CN" b="1" dirty="0"/>
+              <a:t>community vulnerability</a:t>
+            </a:r>
+            <a:r>
+              <a:rPr lang="en-US" altLang="zh-CN" dirty="0"/>
+              <a:t> into one clear priority score.</a:t>
+            </a:r>
+          </a:p>
+          <a:p>
             <a:endParaRPr lang="en-US" dirty="0"/>
           </a:p>
         </p:txBody>
@@ -684,9 +565,81 @@
           <a:lstStyle/>
           <a:p>
             <a:r>
-              <a:rPr lang="en-US" dirty="0"/>
-              <a:t/>
-            </a:r>
+              <a:rPr lang="en-US" altLang="zh-CN" dirty="0"/>
+              <a:t>Our system has three main parts.</a:t>
+            </a:r>
+          </a:p>
+          <a:p>
+            <a:r>
+              <a:rPr lang="en-US" altLang="zh-CN" dirty="0"/>
+              <a:t>First, the </a:t>
+            </a:r>
+            <a:r>
+              <a:rPr lang="en-US" altLang="zh-CN" b="1" dirty="0"/>
+              <a:t>Priority Queue</a:t>
+            </a:r>
+            <a:r>
+              <a:rPr lang="en-US" altLang="zh-CN" dirty="0"/>
+              <a:t>.</a:t>
+            </a:r>
+            <a:br>
+              <a:rPr lang="en-US" altLang="zh-CN" dirty="0"/>
+            </a:br>
+            <a:r>
+              <a:rPr lang="en-US" altLang="zh-CN" dirty="0"/>
+              <a:t>This gives care teams a ranked list of patients, so they can quickly see who may need attention first.</a:t>
+            </a:r>
+          </a:p>
+          <a:p>
+            <a:r>
+              <a:rPr lang="en-US" altLang="zh-CN" dirty="0"/>
+              <a:t>Second, the </a:t>
+            </a:r>
+            <a:r>
+              <a:rPr lang="en-US" altLang="zh-CN" b="1" dirty="0"/>
+              <a:t>Intervention Planner</a:t>
+            </a:r>
+            <a:r>
+              <a:rPr lang="en-US" altLang="zh-CN" dirty="0"/>
+              <a:t>.</a:t>
+            </a:r>
+            <a:br>
+              <a:rPr lang="en-US" altLang="zh-CN" dirty="0"/>
+            </a:br>
+            <a:r>
+              <a:rPr lang="en-US" altLang="zh-CN" dirty="0"/>
+              <a:t>If outreach capacity is limited, this helps teams focus effort where the potential benefit may be greater.</a:t>
+            </a:r>
+          </a:p>
+          <a:p>
+            <a:r>
+              <a:rPr lang="en-US" altLang="zh-CN" dirty="0"/>
+              <a:t>Third, the </a:t>
+            </a:r>
+            <a:r>
+              <a:rPr lang="en-US" altLang="zh-CN" b="1" dirty="0"/>
+              <a:t>Scenario Simulator</a:t>
+            </a:r>
+            <a:r>
+              <a:rPr lang="en-US" altLang="zh-CN" dirty="0"/>
+              <a:t>.</a:t>
+            </a:r>
+            <a:br>
+              <a:rPr lang="en-US" altLang="zh-CN" dirty="0"/>
+            </a:br>
+            <a:r>
+              <a:rPr lang="en-US" altLang="zh-CN" dirty="0"/>
+              <a:t>This is a community-level what-if tool.</a:t>
+            </a:r>
+            <a:br>
+              <a:rPr lang="en-US" altLang="zh-CN" dirty="0"/>
+            </a:br>
+            <a:r>
+              <a:rPr lang="en-US" altLang="zh-CN" dirty="0"/>
+              <a:t>For example, if primary care attachment improves in one community, how might the priority burden change?</a:t>
+            </a:r>
+          </a:p>
+          <a:p>
             <a:endParaRPr lang="en-US" dirty="0"/>
           </a:p>
         </p:txBody>
@@ -772,9 +725,81 @@
           <a:lstStyle/>
           <a:p>
             <a:r>
-              <a:rPr lang="en-US" dirty="0"/>
-              <a:t/>
-            </a:r>
+              <a:rPr lang="en-US" altLang="zh-CN" dirty="0"/>
+              <a:t>To do this, we use two tracks of data.</a:t>
+            </a:r>
+          </a:p>
+          <a:p>
+            <a:r>
+              <a:rPr lang="en-US" altLang="zh-CN" dirty="0"/>
+              <a:t>Track 1 is patient-level data, including encounters, ED visits, labs, medications, and follow-up gaps.</a:t>
+            </a:r>
+          </a:p>
+          <a:p>
+            <a:r>
+              <a:rPr lang="en-US" altLang="zh-CN" dirty="0"/>
+              <a:t>Track 2 is community-level data, including family doctor attachment, poverty, opioid overdose rates, and wait time context.</a:t>
+            </a:r>
+          </a:p>
+          <a:p>
+            <a:r>
+              <a:rPr lang="en-US" altLang="zh-CN" dirty="0"/>
+              <a:t>From these two tracks, we calculate:</a:t>
+            </a:r>
+            <a:br>
+              <a:rPr lang="en-US" altLang="zh-CN" dirty="0"/>
+            </a:br>
+            <a:r>
+              <a:rPr lang="en-US" altLang="zh-CN" dirty="0"/>
+              <a:t>a </a:t>
+            </a:r>
+            <a:r>
+              <a:rPr lang="en-US" altLang="zh-CN" b="1" dirty="0"/>
+              <a:t>Patient Risk Score</a:t>
+            </a:r>
+            <a:r>
+              <a:rPr lang="en-US" altLang="zh-CN" dirty="0"/>
+              <a:t>,</a:t>
+            </a:r>
+            <a:br>
+              <a:rPr lang="en-US" altLang="zh-CN" dirty="0"/>
+            </a:br>
+            <a:r>
+              <a:rPr lang="en-US" altLang="zh-CN" dirty="0"/>
+              <a:t>a </a:t>
+            </a:r>
+            <a:r>
+              <a:rPr lang="en-US" altLang="zh-CN" b="1" dirty="0"/>
+              <a:t>Community Vulnerability Score</a:t>
+            </a:r>
+            <a:r>
+              <a:rPr lang="en-US" altLang="zh-CN" dirty="0"/>
+              <a:t>,</a:t>
+            </a:r>
+            <a:br>
+              <a:rPr lang="en-US" altLang="zh-CN" dirty="0"/>
+            </a:br>
+            <a:r>
+              <a:rPr lang="en-US" altLang="zh-CN" dirty="0"/>
+              <a:t>and then a </a:t>
+            </a:r>
+            <a:r>
+              <a:rPr lang="en-US" altLang="zh-CN" b="1" dirty="0"/>
+              <a:t>Combined Priority Score</a:t>
+            </a:r>
+            <a:r>
+              <a:rPr lang="en-US" altLang="zh-CN" dirty="0"/>
+              <a:t>:</a:t>
+            </a:r>
+            <a:br>
+              <a:rPr lang="en-US" altLang="zh-CN" dirty="0"/>
+            </a:br>
+            <a:r>
+              <a:rPr lang="en-US" altLang="zh-CN" dirty="0"/>
+              <a:t>60 percent clinical and 40 percent community. </a:t>
+            </a:r>
+          </a:p>
+          <a:p>
             <a:endParaRPr lang="en-US" dirty="0"/>
           </a:p>
         </p:txBody>
@@ -860,9 +885,81 @@
           <a:lstStyle/>
           <a:p>
             <a:r>
-              <a:rPr lang="en-US" dirty="0"/>
-              <a:t/>
-            </a:r>
+              <a:rPr lang="en-US" altLang="zh-CN" dirty="0"/>
+              <a:t>The patient score is based on factors like:</a:t>
+            </a:r>
+            <a:br>
+              <a:rPr lang="en-US" altLang="zh-CN" dirty="0"/>
+            </a:br>
+            <a:r>
+              <a:rPr lang="en-US" altLang="zh-CN" dirty="0"/>
+              <a:t>repeat ED visits,</a:t>
+            </a:r>
+            <a:br>
+              <a:rPr lang="en-US" altLang="zh-CN" dirty="0"/>
+            </a:br>
+            <a:r>
+              <a:rPr lang="en-US" altLang="zh-CN" dirty="0"/>
+              <a:t>uncontrolled chronic disease,</a:t>
+            </a:r>
+            <a:br>
+              <a:rPr lang="en-US" altLang="zh-CN" dirty="0"/>
+            </a:br>
+            <a:r>
+              <a:rPr lang="en-US" altLang="zh-CN" dirty="0"/>
+              <a:t>polypharmacy,</a:t>
+            </a:r>
+            <a:br>
+              <a:rPr lang="en-US" altLang="zh-CN" dirty="0"/>
+            </a:br>
+            <a:r>
+              <a:rPr lang="en-US" altLang="zh-CN" dirty="0"/>
+              <a:t>and other follow-up or access-related signals.</a:t>
+            </a:r>
+          </a:p>
+          <a:p>
+            <a:r>
+              <a:rPr lang="en-US" altLang="zh-CN" dirty="0"/>
+              <a:t>Then we assign patients into clear priority tiers,</a:t>
+            </a:r>
+            <a:br>
+              <a:rPr lang="en-US" altLang="zh-CN" dirty="0"/>
+            </a:br>
+            <a:r>
+              <a:rPr lang="en-US" altLang="zh-CN" dirty="0"/>
+              <a:t>from </a:t>
+            </a:r>
+            <a:r>
+              <a:rPr lang="en-US" altLang="zh-CN" b="1" dirty="0"/>
+              <a:t>Critical</a:t>
+            </a:r>
+            <a:r>
+              <a:rPr lang="en-US" altLang="zh-CN" dirty="0"/>
+              <a:t> to </a:t>
+            </a:r>
+            <a:r>
+              <a:rPr lang="en-US" altLang="zh-CN" b="1" dirty="0"/>
+              <a:t>Low</a:t>
+            </a:r>
+            <a:r>
+              <a:rPr lang="en-US" altLang="zh-CN" dirty="0"/>
+              <a:t>.</a:t>
+            </a:r>
+          </a:p>
+          <a:p>
+            <a:r>
+              <a:rPr lang="en-US" altLang="zh-CN" dirty="0"/>
+              <a:t>The main point is that this is not a black box.</a:t>
+            </a:r>
+            <a:br>
+              <a:rPr lang="en-US" altLang="zh-CN" dirty="0"/>
+            </a:br>
+            <a:r>
+              <a:rPr lang="en-US" altLang="zh-CN" dirty="0"/>
+              <a:t>The weights are explicit, and the scoring is fully auditable.</a:t>
+            </a:r>
+          </a:p>
+          <a:p>
             <a:endParaRPr lang="en-US" dirty="0"/>
           </a:p>
         </p:txBody>
@@ -948,9 +1045,76 @@
           <a:lstStyle/>
           <a:p>
             <a:r>
-              <a:rPr lang="en-US" dirty="0"/>
-              <a:t/>
-            </a:r>
+              <a:rPr lang="en-US" altLang="zh-CN" dirty="0"/>
+              <a:t>In our demo, we scored </a:t>
+            </a:r>
+            <a:r>
+              <a:rPr lang="en-US" altLang="zh-CN" b="1" dirty="0"/>
+              <a:t>2,000 patients</a:t>
+            </a:r>
+            <a:r>
+              <a:rPr lang="en-US" altLang="zh-CN" dirty="0"/>
+              <a:t>.</a:t>
+            </a:r>
+            <a:br>
+              <a:rPr lang="en-US" altLang="zh-CN" dirty="0"/>
+            </a:br>
+            <a:r>
+              <a:rPr lang="en-US" altLang="zh-CN" dirty="0"/>
+              <a:t>We identified </a:t>
+            </a:r>
+            <a:r>
+              <a:rPr lang="en-US" altLang="zh-CN" b="1" dirty="0"/>
+              <a:t>349 high-priority patients</a:t>
+            </a:r>
+            <a:r>
+              <a:rPr lang="en-US" altLang="zh-CN" dirty="0"/>
+              <a:t> with limited GP access.</a:t>
+            </a:r>
+            <a:br>
+              <a:rPr lang="en-US" altLang="zh-CN" dirty="0"/>
+            </a:br>
+            <a:r>
+              <a:rPr lang="en-US" altLang="zh-CN" dirty="0"/>
+              <a:t>We also estimated </a:t>
+            </a:r>
+            <a:r>
+              <a:rPr lang="en-US" altLang="zh-CN" b="1" dirty="0"/>
+              <a:t>170 avoidable ED visits per year</a:t>
+            </a:r>
+            <a:r>
+              <a:rPr lang="en-US" altLang="zh-CN" dirty="0"/>
+              <a:t> under our planning assumptions.</a:t>
+            </a:r>
+          </a:p>
+          <a:p>
+            <a:r>
+              <a:rPr lang="en-US" altLang="zh-CN" dirty="0"/>
+              <a:t>So the value of the system is really this:</a:t>
+            </a:r>
+          </a:p>
+          <a:p>
+            <a:r>
+              <a:rPr lang="en-US" altLang="zh-CN" dirty="0"/>
+              <a:t>it does not just show who is sick.</a:t>
+            </a:r>
+            <a:br>
+              <a:rPr lang="en-US" altLang="zh-CN" dirty="0"/>
+            </a:br>
+            <a:r>
+              <a:rPr lang="en-US" altLang="zh-CN" dirty="0"/>
+              <a:t>It helps show who is at higher risk </a:t>
+            </a:r>
+            <a:r>
+              <a:rPr lang="en-US" altLang="zh-CN" b="1" dirty="0"/>
+              <a:t>and</a:t>
+            </a:r>
+            <a:r>
+              <a:rPr lang="en-US" altLang="zh-CN" dirty="0"/>
+              <a:t> more likely to be missed by the system.</a:t>
+            </a:r>
+          </a:p>
+          <a:p>
             <a:endParaRPr lang="en-US" dirty="0"/>
           </a:p>
         </p:txBody>
@@ -1036,9 +1200,58 @@
           <a:lstStyle/>
           <a:p>
             <a:r>
-              <a:rPr lang="en-US" dirty="0"/>
-              <a:t/>
-            </a:r>
+              <a:rPr lang="en-US" altLang="zh-CN" dirty="0"/>
+              <a:t>We also want to be clear about what this tool is, and what it is not.</a:t>
+            </a:r>
+          </a:p>
+          <a:p>
+            <a:r>
+              <a:rPr lang="en-US" altLang="zh-CN" dirty="0"/>
+              <a:t>It is a tool for </a:t>
+            </a:r>
+            <a:r>
+              <a:rPr lang="en-US" altLang="zh-CN" b="1" dirty="0"/>
+              <a:t>prioritization</a:t>
+            </a:r>
+            <a:r>
+              <a:rPr lang="en-US" altLang="zh-CN" dirty="0"/>
+              <a:t>, not diagnosis.</a:t>
+            </a:r>
+            <a:br>
+              <a:rPr lang="en-US" altLang="zh-CN" dirty="0"/>
+            </a:br>
+            <a:r>
+              <a:rPr lang="en-US" altLang="zh-CN" dirty="0"/>
+              <a:t>It does not prove causality.</a:t>
+            </a:r>
+            <a:br>
+              <a:rPr lang="en-US" altLang="zh-CN" dirty="0"/>
+            </a:br>
+            <a:r>
+              <a:rPr lang="en-US" altLang="zh-CN" dirty="0"/>
+              <a:t>And community-level statistics are not the same as individual-level truth.</a:t>
+            </a:r>
+          </a:p>
+          <a:p>
+            <a:r>
+              <a:rPr lang="en-US" altLang="zh-CN" dirty="0"/>
+              <a:t>That is why we made the scoring transparent, the reasoning visible, and the limitations explicit.</a:t>
+            </a:r>
+          </a:p>
+          <a:p>
+            <a:r>
+              <a:rPr lang="en-US" altLang="zh-CN" dirty="0"/>
+              <a:t>We believe a trustworthy tool should not hide uncertainty.</a:t>
+            </a:r>
+            <a:br>
+              <a:rPr lang="en-US" altLang="zh-CN" dirty="0"/>
+            </a:br>
+            <a:r>
+              <a:rPr lang="en-US" altLang="zh-CN" dirty="0"/>
+              <a:t>It should show what it knows, and also what it does not know.</a:t>
+            </a:r>
+          </a:p>
+          <a:p>
             <a:endParaRPr lang="en-US" dirty="0"/>
           </a:p>
         </p:txBody>
@@ -1124,9 +1337,23 @@
           <a:lstStyle/>
           <a:p>
             <a:r>
-              <a:rPr lang="en-US" dirty="0"/>
-              <a:t/>
-            </a:r>
+              <a:rPr lang="en-US" altLang="zh-CN" dirty="0"/>
+              <a:t>So in one sentence:</a:t>
+            </a:r>
+          </a:p>
+          <a:p>
+            <a:r>
+              <a:rPr lang="en-US" altLang="zh-CN" dirty="0"/>
+              <a:t>Our project helps care teams use limited resources more effectively, and more equitably.</a:t>
+            </a:r>
+          </a:p>
+          <a:p>
+            <a:r>
+              <a:rPr lang="en-US" altLang="zh-CN" dirty="0"/>
+              <a:t>Thank you.</a:t>
+            </a:r>
+          </a:p>
+          <a:p>
             <a:endParaRPr lang="en-US" dirty="0"/>
           </a:p>
         </p:txBody>
@@ -1200,6 +1427,11 @@
 <file path=ppt/slideMasters/slideMaster1.xml><?xml version="1.0" encoding="utf-8"?>
 <p:sldMaster xmlns:a="http://schemas.openxmlformats.org/drawingml/2006/main" xmlns:r="http://schemas.openxmlformats.org/officeDocument/2006/relationships" xmlns:p="http://schemas.openxmlformats.org/presentationml/2006/main">
   <p:cSld>
+    <p:bg>
+      <p:bgRef idx="1001">
+        <a:schemeClr val="bg1"/>
+      </p:bgRef>
+    </p:bg>
     <p:spTree>
       <p:nvGrpSpPr>
         <p:cNvPr id="1" name=""/>
@@ -1482,6 +1714,7 @@
         <a:solidFill>
           <a:srgbClr val="0B2545"/>
         </a:solidFill>
+        <a:effectLst/>
       </p:bgPr>
     </p:bg>
     <p:spTree>
@@ -1539,7 +1772,7 @@
           <a:bodyPr wrap="square" lIns="0" tIns="0" rIns="0" bIns="0" rtlCol="0" anchor="ctr"/>
           <a:lstStyle/>
           <a:p>
-            <a:pPr indent="0" marL="0">
+            <a:pPr marL="0" indent="0">
               <a:lnSpc>
                 <a:spcPct val="110000"/>
               </a:lnSpc>
@@ -1559,7 +1792,7 @@
             <a:endParaRPr lang="en-US" sz="4000" dirty="0"/>
           </a:p>
           <a:p>
-            <a:pPr indent="0" marL="0">
+            <a:pPr marL="0" indent="0">
               <a:lnSpc>
                 <a:spcPct val="110000"/>
               </a:lnSpc>
@@ -1601,7 +1834,7 @@
           <a:bodyPr wrap="square" lIns="0" tIns="0" rIns="0" bIns="0" rtlCol="0" anchor="ctr"/>
           <a:lstStyle/>
           <a:p>
-            <a:pPr indent="0" marL="0">
+            <a:pPr marL="0" indent="0">
               <a:buNone/>
             </a:pPr>
             <a:r>
@@ -1663,7 +1896,7 @@
           <a:bodyPr wrap="square" lIns="0" tIns="0" rIns="0" bIns="0" rtlCol="0" anchor="ctr"/>
           <a:lstStyle/>
           <a:p>
-            <a:pPr indent="0" marL="0">
+            <a:pPr marL="0" indent="0">
               <a:buNone/>
             </a:pPr>
             <a:r>
@@ -1702,7 +1935,7 @@
           <a:bodyPr wrap="square" lIns="0" tIns="0" rIns="0" bIns="0" rtlCol="0" anchor="ctr"/>
           <a:lstStyle/>
           <a:p>
-            <a:pPr indent="0" marL="0">
+            <a:pPr marL="0" indent="0">
               <a:buNone/>
             </a:pPr>
             <a:r>
@@ -1736,6 +1969,7 @@
         <a:solidFill>
           <a:srgbClr val="F0F4F8"/>
         </a:solidFill>
+        <a:effectLst/>
       </p:bgPr>
     </p:bg>
     <p:spTree>
@@ -1773,7 +2007,7 @@
           <a:bodyPr wrap="square" lIns="0" tIns="0" rIns="0" bIns="0" rtlCol="0" anchor="ctr"/>
           <a:lstStyle/>
           <a:p>
-            <a:pPr indent="0" marL="0">
+            <a:pPr marL="0" indent="0">
               <a:buNone/>
             </a:pPr>
             <a:r>
@@ -1810,7 +2044,7 @@
           </a:solidFill>
           <a:ln/>
           <a:effectLst>
-            <a:outerShdw sx="100000" sy="100000" kx="0" ky="0" algn="bl" rotWithShape="0" blurRad="76200" dist="25400" dir="8100000">
+            <a:outerShdw blurRad="76200" dist="25400" dir="8100000" algn="bl" rotWithShape="0">
               <a:srgbClr val="000000">
                 <a:alpha val="12000"/>
               </a:srgbClr>
@@ -1859,7 +2093,7 @@
           <a:bodyPr wrap="square" lIns="0" tIns="0" rIns="0" bIns="0" rtlCol="0" anchor="ctr"/>
           <a:lstStyle/>
           <a:p>
-            <a:pPr indent="0" marL="0">
+            <a:pPr marL="0" indent="0">
               <a:buNone/>
             </a:pPr>
             <a:r>
@@ -1898,7 +2132,7 @@
           <a:bodyPr wrap="square" lIns="0" tIns="0" rIns="0" bIns="0" rtlCol="0" anchor="ctr"/>
           <a:lstStyle/>
           <a:p>
-            <a:pPr indent="0" marL="0">
+            <a:pPr marL="0" indent="0">
               <a:buNone/>
             </a:pPr>
             <a:r>
@@ -1935,7 +2169,7 @@
           </a:solidFill>
           <a:ln/>
           <a:effectLst>
-            <a:outerShdw sx="100000" sy="100000" kx="0" ky="0" algn="bl" rotWithShape="0" blurRad="76200" dist="25400" dir="8100000">
+            <a:outerShdw blurRad="76200" dist="25400" dir="8100000" algn="bl" rotWithShape="0">
               <a:srgbClr val="000000">
                 <a:alpha val="12000"/>
               </a:srgbClr>
@@ -1984,7 +2218,7 @@
           <a:bodyPr wrap="square" lIns="0" tIns="0" rIns="0" bIns="0" rtlCol="0" anchor="ctr"/>
           <a:lstStyle/>
           <a:p>
-            <a:pPr indent="0" marL="0">
+            <a:pPr marL="0" indent="0">
               <a:buNone/>
             </a:pPr>
             <a:r>
@@ -2023,7 +2257,7 @@
           <a:bodyPr wrap="square" lIns="0" tIns="0" rIns="0" bIns="0" rtlCol="0" anchor="ctr"/>
           <a:lstStyle/>
           <a:p>
-            <a:pPr indent="0" marL="0">
+            <a:pPr marL="0" indent="0">
               <a:buNone/>
             </a:pPr>
             <a:r>
@@ -2040,7 +2274,7 @@
             <a:endParaRPr lang="en-US" sz="1400" dirty="0"/>
           </a:p>
           <a:p>
-            <a:pPr indent="0" marL="0">
+            <a:pPr marL="0" indent="0">
               <a:buNone/>
             </a:pPr>
             <a:r>
@@ -2180,6 +2414,7 @@
         <a:solidFill>
           <a:srgbClr val="FFFFFF"/>
         </a:solidFill>
+        <a:effectLst/>
       </p:bgPr>
     </p:bg>
     <p:spTree>
@@ -2217,7 +2452,7 @@
           <a:bodyPr wrap="square" lIns="0" tIns="0" rIns="0" bIns="0" rtlCol="0" anchor="ctr"/>
           <a:lstStyle/>
           <a:p>
-            <a:pPr indent="0" marL="0">
+            <a:pPr marL="0" indent="0">
               <a:buNone/>
             </a:pPr>
             <a:r>
@@ -2256,7 +2491,7 @@
           <a:bodyPr wrap="square" lIns="0" tIns="0" rIns="0" bIns="0" rtlCol="0" anchor="ctr"/>
           <a:lstStyle/>
           <a:p>
-            <a:pPr indent="0" marL="0">
+            <a:pPr marL="0" indent="0">
               <a:buNone/>
             </a:pPr>
             <a:r>
@@ -2293,7 +2528,7 @@
           </a:solidFill>
           <a:ln/>
           <a:effectLst>
-            <a:outerShdw sx="100000" sy="100000" kx="0" ky="0" algn="bl" rotWithShape="0" blurRad="76200" dist="25400" dir="8100000">
+            <a:outerShdw blurRad="76200" dist="25400" dir="8100000" algn="bl" rotWithShape="0">
               <a:srgbClr val="000000">
                 <a:alpha val="12000"/>
               </a:srgbClr>
@@ -2342,7 +2577,7 @@
           <a:bodyPr wrap="square" lIns="0" tIns="0" rIns="0" bIns="0" rtlCol="0" anchor="ctr"/>
           <a:lstStyle/>
           <a:p>
-            <a:pPr indent="0" marL="0">
+            <a:pPr marL="0" indent="0">
               <a:buNone/>
             </a:pPr>
             <a:r>
@@ -2381,7 +2616,7 @@
           <a:bodyPr wrap="square" lIns="0" tIns="0" rIns="0" bIns="0" rtlCol="0" anchor="ctr"/>
           <a:lstStyle/>
           <a:p>
-            <a:pPr indent="0" marL="0">
+            <a:pPr marL="0" indent="0">
               <a:buNone/>
             </a:pPr>
             <a:r>
@@ -2398,7 +2633,7 @@
             <a:endParaRPr lang="en-US" sz="1300" dirty="0"/>
           </a:p>
           <a:p>
-            <a:pPr indent="0" marL="0">
+            <a:pPr marL="0" indent="0">
               <a:buNone/>
             </a:pPr>
             <a:r>
@@ -2415,7 +2650,7 @@
             <a:endParaRPr lang="en-US" sz="1300" dirty="0"/>
           </a:p>
           <a:p>
-            <a:pPr indent="0" marL="0">
+            <a:pPr marL="0" indent="0">
               <a:buNone/>
             </a:pPr>
             <a:r>
@@ -2432,7 +2667,7 @@
             <a:endParaRPr lang="en-US" sz="1300" dirty="0"/>
           </a:p>
           <a:p>
-            <a:pPr indent="0" marL="0">
+            <a:pPr marL="0" indent="0">
               <a:buNone/>
             </a:pPr>
             <a:r>
@@ -2469,7 +2704,7 @@
           </a:solidFill>
           <a:ln/>
           <a:effectLst>
-            <a:outerShdw sx="100000" sy="100000" kx="0" ky="0" algn="bl" rotWithShape="0" blurRad="76200" dist="25400" dir="8100000">
+            <a:outerShdw blurRad="76200" dist="25400" dir="8100000" algn="bl" rotWithShape="0">
               <a:srgbClr val="000000">
                 <a:alpha val="12000"/>
               </a:srgbClr>
@@ -2518,7 +2753,7 @@
           <a:bodyPr wrap="square" lIns="0" tIns="0" rIns="0" bIns="0" rtlCol="0" anchor="ctr"/>
           <a:lstStyle/>
           <a:p>
-            <a:pPr indent="0" marL="0">
+            <a:pPr marL="0" indent="0">
               <a:buNone/>
             </a:pPr>
             <a:r>
@@ -2557,7 +2792,7 @@
           <a:bodyPr wrap="square" lIns="0" tIns="0" rIns="0" bIns="0" rtlCol="0" anchor="ctr"/>
           <a:lstStyle/>
           <a:p>
-            <a:pPr indent="0" marL="0">
+            <a:pPr marL="0" indent="0">
               <a:buNone/>
             </a:pPr>
             <a:r>
@@ -2574,7 +2809,7 @@
             <a:endParaRPr lang="en-US" sz="1300" dirty="0"/>
           </a:p>
           <a:p>
-            <a:pPr indent="0" marL="0">
+            <a:pPr marL="0" indent="0">
               <a:buNone/>
             </a:pPr>
             <a:r>
@@ -2591,7 +2826,7 @@
             <a:endParaRPr lang="en-US" sz="1300" dirty="0"/>
           </a:p>
           <a:p>
-            <a:pPr indent="0" marL="0">
+            <a:pPr marL="0" indent="0">
               <a:buNone/>
             </a:pPr>
             <a:r>
@@ -2608,7 +2843,7 @@
             <a:endParaRPr lang="en-US" sz="1300" dirty="0"/>
           </a:p>
           <a:p>
-            <a:pPr indent="0" marL="0">
+            <a:pPr marL="0" indent="0">
               <a:buNone/>
             </a:pPr>
             <a:r>
@@ -2645,7 +2880,7 @@
           </a:solidFill>
           <a:ln/>
           <a:effectLst>
-            <a:outerShdw sx="100000" sy="100000" kx="0" ky="0" algn="bl" rotWithShape="0" blurRad="76200" dist="25400" dir="8100000">
+            <a:outerShdw blurRad="76200" dist="25400" dir="8100000" algn="bl" rotWithShape="0">
               <a:srgbClr val="000000">
                 <a:alpha val="12000"/>
               </a:srgbClr>
@@ -2694,7 +2929,7 @@
           <a:bodyPr wrap="square" lIns="0" tIns="0" rIns="0" bIns="0" rtlCol="0" anchor="ctr"/>
           <a:lstStyle/>
           <a:p>
-            <a:pPr indent="0" marL="0">
+            <a:pPr marL="0" indent="0">
               <a:buNone/>
             </a:pPr>
             <a:r>
@@ -2733,7 +2968,7 @@
           <a:bodyPr wrap="square" lIns="0" tIns="0" rIns="0" bIns="0" rtlCol="0" anchor="ctr"/>
           <a:lstStyle/>
           <a:p>
-            <a:pPr indent="0" marL="0">
+            <a:pPr marL="0" indent="0">
               <a:buNone/>
             </a:pPr>
             <a:r>
@@ -2750,7 +2985,7 @@
             <a:endParaRPr lang="en-US" sz="1300" dirty="0"/>
           </a:p>
           <a:p>
-            <a:pPr indent="0" marL="0">
+            <a:pPr marL="0" indent="0">
               <a:buNone/>
             </a:pPr>
             <a:r>
@@ -2767,7 +3002,7 @@
             <a:endParaRPr lang="en-US" sz="1300" dirty="0"/>
           </a:p>
           <a:p>
-            <a:pPr indent="0" marL="0">
+            <a:pPr marL="0" indent="0">
               <a:buNone/>
             </a:pPr>
             <a:r>
@@ -2784,7 +3019,7 @@
             <a:endParaRPr lang="en-US" sz="1300" dirty="0"/>
           </a:p>
           <a:p>
-            <a:pPr indent="0" marL="0">
+            <a:pPr marL="0" indent="0">
               <a:buNone/>
             </a:pPr>
             <a:r>
@@ -2823,7 +3058,7 @@
           <a:bodyPr wrap="square" lIns="0" tIns="0" rIns="0" bIns="0" rtlCol="0" anchor="ctr"/>
           <a:lstStyle/>
           <a:p>
-            <a:pPr indent="0" marL="0">
+            <a:pPr marL="0" indent="0">
               <a:buNone/>
             </a:pPr>
             <a:r>
@@ -2857,6 +3092,7 @@
         <a:solidFill>
           <a:srgbClr val="FFFFFF"/>
         </a:solidFill>
+        <a:effectLst/>
       </p:bgPr>
     </p:bg>
     <p:spTree>
@@ -2894,7 +3130,7 @@
           <a:bodyPr wrap="square" lIns="0" tIns="0" rIns="0" bIns="0" rtlCol="0" anchor="ctr"/>
           <a:lstStyle/>
           <a:p>
-            <a:pPr indent="0" marL="0">
+            <a:pPr marL="0" indent="0">
               <a:buNone/>
             </a:pPr>
             <a:r>
@@ -2931,7 +3167,7 @@
           </a:solidFill>
           <a:ln/>
           <a:effectLst>
-            <a:outerShdw sx="100000" sy="100000" kx="0" ky="0" algn="bl" rotWithShape="0" blurRad="76200" dist="25400" dir="8100000">
+            <a:outerShdw blurRad="76200" dist="25400" dir="8100000" algn="bl" rotWithShape="0">
               <a:srgbClr val="000000">
                 <a:alpha val="12000"/>
               </a:srgbClr>
@@ -2960,7 +3196,7 @@
           <a:bodyPr wrap="square" lIns="0" tIns="0" rIns="0" bIns="0" rtlCol="0" anchor="ctr"/>
           <a:lstStyle/>
           <a:p>
-            <a:pPr indent="0" marL="0">
+            <a:pPr marL="0" indent="0">
               <a:buNone/>
             </a:pPr>
             <a:r>
@@ -3103,7 +3339,7 @@
           </a:solidFill>
           <a:ln/>
           <a:effectLst>
-            <a:outerShdw sx="100000" sy="100000" kx="0" ky="0" algn="bl" rotWithShape="0" blurRad="76200" dist="25400" dir="8100000">
+            <a:outerShdw blurRad="76200" dist="25400" dir="8100000" algn="bl" rotWithShape="0">
               <a:srgbClr val="000000">
                 <a:alpha val="12000"/>
               </a:srgbClr>
@@ -3132,7 +3368,7 @@
           <a:bodyPr wrap="square" lIns="0" tIns="0" rIns="0" bIns="0" rtlCol="0" anchor="ctr"/>
           <a:lstStyle/>
           <a:p>
-            <a:pPr indent="0" marL="0">
+            <a:pPr marL="0" indent="0">
               <a:buNone/>
             </a:pPr>
             <a:r>
@@ -3277,7 +3513,7 @@
           <a:bodyPr wrap="square" lIns="0" tIns="0" rIns="0" bIns="0" rtlCol="0" anchor="ctr"/>
           <a:lstStyle/>
           <a:p>
-            <a:pPr algn="ctr" indent="0" marL="0">
+            <a:pPr marL="0" indent="0" algn="ctr">
               <a:buNone/>
             </a:pPr>
             <a:r>
@@ -3313,7 +3549,7 @@
           <a:bodyPr wrap="square" lIns="0" tIns="0" rIns="0" bIns="0" rtlCol="0" anchor="ctr"/>
           <a:lstStyle/>
           <a:p>
-            <a:pPr algn="ctr" indent="0" marL="0">
+            <a:pPr marL="0" indent="0" algn="ctr">
               <a:buNone/>
             </a:pPr>
             <a:r>
@@ -3369,7 +3605,7 @@
           <a:bodyPr wrap="square" lIns="0" tIns="0" rIns="0" bIns="0" rtlCol="0" anchor="ctr"/>
           <a:lstStyle/>
           <a:p>
-            <a:pPr algn="ctr" indent="0" marL="0">
+            <a:pPr marL="0" indent="0" algn="ctr">
               <a:buNone/>
             </a:pPr>
             <a:r>
@@ -3428,7 +3664,7 @@
           <a:bodyPr wrap="square" lIns="0" tIns="0" rIns="0" bIns="0" rtlCol="0" anchor="ctr"/>
           <a:lstStyle/>
           <a:p>
-            <a:pPr algn="ctr" indent="0" marL="0">
+            <a:pPr marL="0" indent="0" algn="ctr">
               <a:buNone/>
             </a:pPr>
             <a:r>
@@ -3467,7 +3703,7 @@
           <a:bodyPr wrap="square" lIns="0" tIns="0" rIns="0" bIns="0" rtlCol="0" anchor="ctr"/>
           <a:lstStyle/>
           <a:p>
-            <a:pPr algn="ctr" indent="0" marL="0">
+            <a:pPr marL="0" indent="0" algn="ctr">
               <a:buNone/>
             </a:pPr>
             <a:r>
@@ -3503,7 +3739,7 @@
           <a:bodyPr wrap="square" lIns="0" tIns="0" rIns="0" bIns="0" rtlCol="0" anchor="ctr"/>
           <a:lstStyle/>
           <a:p>
-            <a:pPr algn="ctr" indent="0" marL="0">
+            <a:pPr marL="0" indent="0" algn="ctr">
               <a:buNone/>
             </a:pPr>
             <a:r>
@@ -3537,7 +3773,7 @@
           </a:solidFill>
           <a:ln/>
           <a:effectLst>
-            <a:outerShdw sx="100000" sy="100000" kx="0" ky="0" algn="bl" rotWithShape="0" blurRad="76200" dist="25400" dir="8100000">
+            <a:outerShdw blurRad="76200" dist="25400" dir="8100000" algn="bl" rotWithShape="0">
               <a:srgbClr val="000000">
                 <a:alpha val="12000"/>
               </a:srgbClr>
@@ -3566,7 +3802,7 @@
           <a:bodyPr wrap="square" lIns="0" tIns="0" rIns="0" bIns="0" rtlCol="0" anchor="ctr"/>
           <a:lstStyle/>
           <a:p>
-            <a:pPr algn="ctr" indent="0" marL="0">
+            <a:pPr marL="0" indent="0" algn="ctr">
               <a:buNone/>
             </a:pPr>
             <a:r>
@@ -3605,7 +3841,7 @@
           <a:bodyPr wrap="square" lIns="0" tIns="0" rIns="0" bIns="0" rtlCol="0" anchor="ctr"/>
           <a:lstStyle/>
           <a:p>
-            <a:pPr algn="ctr" indent="0" marL="0">
+            <a:pPr marL="0" indent="0" algn="ctr">
               <a:buNone/>
             </a:pPr>
             <a:r>
@@ -3644,7 +3880,7 @@
           <a:bodyPr wrap="square" lIns="0" tIns="0" rIns="0" bIns="0" rtlCol="0" anchor="ctr"/>
           <a:lstStyle/>
           <a:p>
-            <a:pPr algn="ctr" indent="0" marL="0">
+            <a:pPr marL="0" indent="0" algn="ctr">
               <a:buNone/>
             </a:pPr>
             <a:r>
@@ -3680,7 +3916,7 @@
           <a:bodyPr wrap="square" lIns="0" tIns="0" rIns="0" bIns="0" rtlCol="0" anchor="ctr"/>
           <a:lstStyle/>
           <a:p>
-            <a:pPr indent="0" marL="0">
+            <a:pPr marL="0" indent="0">
               <a:buNone/>
             </a:pPr>
             <a:r>
@@ -3714,6 +3950,7 @@
         <a:solidFill>
           <a:srgbClr val="F0F4F8"/>
         </a:solidFill>
+        <a:effectLst/>
       </p:bgPr>
     </p:bg>
     <p:spTree>
@@ -3751,7 +3988,7 @@
           <a:bodyPr wrap="square" lIns="0" tIns="0" rIns="0" bIns="0" rtlCol="0" anchor="ctr"/>
           <a:lstStyle/>
           <a:p>
-            <a:pPr indent="0" marL="0">
+            <a:pPr marL="0" indent="0">
               <a:buNone/>
             </a:pPr>
             <a:r>
@@ -3790,7 +4027,7 @@
           <a:bodyPr wrap="square" lIns="0" tIns="0" rIns="0" bIns="0" rtlCol="0" anchor="ctr"/>
           <a:lstStyle/>
           <a:p>
-            <a:pPr indent="0" marL="0">
+            <a:pPr marL="0" indent="0">
               <a:buNone/>
             </a:pPr>
             <a:r>
@@ -3824,15 +4061,27 @@
         </p:nvGraphicFramePr>
         <p:xfrm>
           <a:off x="731520" y="1463040"/>
-          <a:ext cx="3840480" cy="914400"/>
+          <a:ext cx="3840480" cy="1389888"/>
         </p:xfrm>
         <a:graphic>
           <a:graphicData uri="http://schemas.openxmlformats.org/drawingml/2006/table">
             <a:tbl>
               <a:tblPr/>
               <a:tblGrid>
-                <a:gridCol w="2926080"/>
-                <a:gridCol w="914400"/>
+                <a:gridCol w="2926080">
+                  <a:extLst>
+                    <a:ext uri="{9D8B030D-6E8A-4147-A177-3AD203B41FA5}">
+                      <a16:colId xmlns:a16="http://schemas.microsoft.com/office/drawing/2014/main" val="20000"/>
+                    </a:ext>
+                  </a:extLst>
+                </a:gridCol>
+                <a:gridCol w="914400">
+                  <a:extLst>
+                    <a:ext uri="{9D8B030D-6E8A-4147-A177-3AD203B41FA5}">
+                      <a16:colId xmlns:a16="http://schemas.microsoft.com/office/drawing/2014/main" val="20001"/>
+                    </a:ext>
+                  </a:extLst>
+                </a:gridCol>
               </a:tblGrid>
               <a:tr h="347472">
                 <a:tc>
@@ -3840,7 +4089,7 @@
                     <a:bodyPr/>
                     <a:lstStyle/>
                     <a:p>
-                      <a:pPr indent="0" marL="0">
+                      <a:pPr marL="0" indent="0">
                         <a:buNone/>
                       </a:pPr>
                       <a:r>
@@ -3861,7 +4110,7 @@
                       </a:endParaRPr>
                     </a:p>
                   </a:txBody>
-                  <a:tcPr marL="91440" marR="91440" marT="45720" marB="45720">
+                  <a:tcPr>
                     <a:lnL w="0" cap="flat" cmpd="sng" algn="ctr">
                       <a:noFill/>
                     </a:lnL>
@@ -3884,7 +4133,7 @@
                     <a:bodyPr/>
                     <a:lstStyle/>
                     <a:p>
-                      <a:pPr algn="r" indent="0" marL="0">
+                      <a:pPr marL="0" indent="0" algn="r">
                         <a:buNone/>
                       </a:pPr>
                       <a:r>
@@ -3905,7 +4154,7 @@
                       </a:endParaRPr>
                     </a:p>
                   </a:txBody>
-                  <a:tcPr marL="91440" marR="91440" marT="45720" marB="45720">
+                  <a:tcPr>
                     <a:lnL w="0" cap="flat" cmpd="sng" algn="ctr">
                       <a:noFill/>
                     </a:lnL>
@@ -3923,6 +4172,11 @@
                     </a:solidFill>
                   </a:tcPr>
                 </a:tc>
+                <a:extLst>
+                  <a:ext uri="{0D108BD9-81ED-4DB2-BD59-A6C34878D82A}">
+                    <a16:rowId xmlns:a16="http://schemas.microsoft.com/office/drawing/2014/main" val="10000"/>
+                  </a:ext>
+                </a:extLst>
               </a:tr>
               <a:tr h="347472">
                 <a:tc>
@@ -3930,7 +4184,7 @@
                     <a:bodyPr/>
                     <a:lstStyle/>
                     <a:p>
-                      <a:pPr indent="0" marL="0">
+                      <a:pPr marL="0" indent="0">
                         <a:buNone/>
                       </a:pPr>
                       <a:r>
@@ -3951,7 +4205,7 @@
                       </a:endParaRPr>
                     </a:p>
                   </a:txBody>
-                  <a:tcPr marL="91440" marR="91440" marT="45720" marB="45720">
+                  <a:tcPr>
                     <a:lnL w="0" cap="flat" cmpd="sng" algn="ctr">
                       <a:noFill/>
                     </a:lnL>
@@ -3974,7 +4228,7 @@
                     <a:bodyPr/>
                     <a:lstStyle/>
                     <a:p>
-                      <a:pPr algn="r" indent="0" marL="0">
+                      <a:pPr marL="0" indent="0" algn="r">
                         <a:buNone/>
                       </a:pPr>
                       <a:r>
@@ -3995,7 +4249,7 @@
                       </a:endParaRPr>
                     </a:p>
                   </a:txBody>
-                  <a:tcPr marL="91440" marR="91440" marT="45720" marB="45720">
+                  <a:tcPr>
                     <a:lnL w="0" cap="flat" cmpd="sng" algn="ctr">
                       <a:noFill/>
                     </a:lnL>
@@ -4013,6 +4267,11 @@
                     </a:solidFill>
                   </a:tcPr>
                 </a:tc>
+                <a:extLst>
+                  <a:ext uri="{0D108BD9-81ED-4DB2-BD59-A6C34878D82A}">
+                    <a16:rowId xmlns:a16="http://schemas.microsoft.com/office/drawing/2014/main" val="10001"/>
+                  </a:ext>
+                </a:extLst>
               </a:tr>
               <a:tr h="347472">
                 <a:tc>
@@ -4020,7 +4279,7 @@
                     <a:bodyPr/>
                     <a:lstStyle/>
                     <a:p>
-                      <a:pPr indent="0" marL="0">
+                      <a:pPr marL="0" indent="0">
                         <a:buNone/>
                       </a:pPr>
                       <a:r>
@@ -4041,7 +4300,7 @@
                       </a:endParaRPr>
                     </a:p>
                   </a:txBody>
-                  <a:tcPr marL="91440" marR="91440" marT="45720" marB="45720">
+                  <a:tcPr>
                     <a:lnL w="0" cap="flat" cmpd="sng" algn="ctr">
                       <a:noFill/>
                     </a:lnL>
@@ -4064,7 +4323,7 @@
                     <a:bodyPr/>
                     <a:lstStyle/>
                     <a:p>
-                      <a:pPr algn="r" indent="0" marL="0">
+                      <a:pPr marL="0" indent="0" algn="r">
                         <a:buNone/>
                       </a:pPr>
                       <a:r>
@@ -4085,7 +4344,7 @@
                       </a:endParaRPr>
                     </a:p>
                   </a:txBody>
-                  <a:tcPr marL="91440" marR="91440" marT="45720" marB="45720">
+                  <a:tcPr>
                     <a:lnL w="0" cap="flat" cmpd="sng" algn="ctr">
                       <a:noFill/>
                     </a:lnL>
@@ -4103,6 +4362,11 @@
                     </a:solidFill>
                   </a:tcPr>
                 </a:tc>
+                <a:extLst>
+                  <a:ext uri="{0D108BD9-81ED-4DB2-BD59-A6C34878D82A}">
+                    <a16:rowId xmlns:a16="http://schemas.microsoft.com/office/drawing/2014/main" val="10002"/>
+                  </a:ext>
+                </a:extLst>
               </a:tr>
               <a:tr h="347472">
                 <a:tc>
@@ -4110,7 +4374,7 @@
                     <a:bodyPr/>
                     <a:lstStyle/>
                     <a:p>
-                      <a:pPr indent="0" marL="0">
+                      <a:pPr marL="0" indent="0">
                         <a:buNone/>
                       </a:pPr>
                       <a:r>
@@ -4131,7 +4395,7 @@
                       </a:endParaRPr>
                     </a:p>
                   </a:txBody>
-                  <a:tcPr marL="91440" marR="91440" marT="45720" marB="45720">
+                  <a:tcPr>
                     <a:lnL w="0" cap="flat" cmpd="sng" algn="ctr">
                       <a:noFill/>
                     </a:lnL>
@@ -4154,7 +4418,7 @@
                     <a:bodyPr/>
                     <a:lstStyle/>
                     <a:p>
-                      <a:pPr algn="r" indent="0" marL="0">
+                      <a:pPr marL="0" indent="0" algn="r">
                         <a:buNone/>
                       </a:pPr>
                       <a:r>
@@ -4175,7 +4439,7 @@
                       </a:endParaRPr>
                     </a:p>
                   </a:txBody>
-                  <a:tcPr marL="91440" marR="91440" marT="45720" marB="45720">
+                  <a:tcPr>
                     <a:lnL w="0" cap="flat" cmpd="sng" algn="ctr">
                       <a:noFill/>
                     </a:lnL>
@@ -4193,6 +4457,11 @@
                     </a:solidFill>
                   </a:tcPr>
                 </a:tc>
+                <a:extLst>
+                  <a:ext uri="{0D108BD9-81ED-4DB2-BD59-A6C34878D82A}">
+                    <a16:rowId xmlns:a16="http://schemas.microsoft.com/office/drawing/2014/main" val="10003"/>
+                  </a:ext>
+                </a:extLst>
               </a:tr>
             </a:tbl>
           </a:graphicData>
@@ -4219,7 +4488,7 @@
           <a:bodyPr wrap="square" lIns="0" tIns="0" rIns="0" bIns="0" rtlCol="0" anchor="ctr"/>
           <a:lstStyle/>
           <a:p>
-            <a:pPr indent="0" marL="0">
+            <a:pPr marL="0" indent="0">
               <a:buNone/>
             </a:pPr>
             <a:r>
@@ -4239,7 +4508,7 @@
       </p:sp>
       <p:sp>
         <p:nvSpPr>
-          <p:cNvPr id="6" name="Text 3"/>
+          <p:cNvPr id="4" name="Text 3"/>
           <p:cNvSpPr/>
           <p:nvPr/>
         </p:nvSpPr>
@@ -4258,7 +4527,7 @@
           <a:bodyPr wrap="square" lIns="0" tIns="0" rIns="0" bIns="0" rtlCol="0" anchor="ctr"/>
           <a:lstStyle/>
           <a:p>
-            <a:pPr indent="0" marL="0">
+            <a:pPr marL="0" indent="0">
               <a:buNone/>
             </a:pPr>
             <a:r>
@@ -4295,7 +4564,7 @@
           </a:solidFill>
           <a:ln/>
           <a:effectLst>
-            <a:outerShdw sx="100000" sy="100000" kx="0" ky="0" algn="bl" rotWithShape="0" blurRad="76200" dist="25400" dir="8100000">
+            <a:outerShdw blurRad="76200" dist="25400" dir="8100000" algn="bl" rotWithShape="0">
               <a:srgbClr val="000000">
                 <a:alpha val="12000"/>
               </a:srgbClr>
@@ -4344,7 +4613,7 @@
           <a:bodyPr wrap="square" lIns="0" tIns="0" rIns="0" bIns="0" rtlCol="0" anchor="ctr"/>
           <a:lstStyle/>
           <a:p>
-            <a:pPr indent="0" marL="0">
+            <a:pPr marL="0" indent="0">
               <a:buNone/>
             </a:pPr>
             <a:r>
@@ -4383,7 +4652,7 @@
           <a:bodyPr wrap="square" lIns="0" tIns="0" rIns="0" bIns="0" rtlCol="0" anchor="ctr"/>
           <a:lstStyle/>
           <a:p>
-            <a:pPr indent="0" marL="0">
+            <a:pPr marL="0" indent="0">
               <a:buNone/>
             </a:pPr>
             <a:r>
@@ -4422,7 +4691,7 @@
           <a:bodyPr wrap="square" lIns="0" tIns="0" rIns="0" bIns="0" rtlCol="0" anchor="ctr"/>
           <a:lstStyle/>
           <a:p>
-            <a:pPr indent="0" marL="0">
+            <a:pPr marL="0" indent="0">
               <a:buNone/>
             </a:pPr>
             <a:r>
@@ -4459,7 +4728,7 @@
           </a:solidFill>
           <a:ln/>
           <a:effectLst>
-            <a:outerShdw sx="100000" sy="100000" kx="0" ky="0" algn="bl" rotWithShape="0" blurRad="76200" dist="25400" dir="8100000">
+            <a:outerShdw blurRad="76200" dist="25400" dir="8100000" algn="bl" rotWithShape="0">
               <a:srgbClr val="000000">
                 <a:alpha val="12000"/>
               </a:srgbClr>
@@ -4508,7 +4777,7 @@
           <a:bodyPr wrap="square" lIns="0" tIns="0" rIns="0" bIns="0" rtlCol="0" anchor="ctr"/>
           <a:lstStyle/>
           <a:p>
-            <a:pPr indent="0" marL="0">
+            <a:pPr marL="0" indent="0">
               <a:buNone/>
             </a:pPr>
             <a:r>
@@ -4547,7 +4816,7 @@
           <a:bodyPr wrap="square" lIns="0" tIns="0" rIns="0" bIns="0" rtlCol="0" anchor="ctr"/>
           <a:lstStyle/>
           <a:p>
-            <a:pPr indent="0" marL="0">
+            <a:pPr marL="0" indent="0">
               <a:buNone/>
             </a:pPr>
             <a:r>
@@ -4586,7 +4855,7 @@
           <a:bodyPr wrap="square" lIns="0" tIns="0" rIns="0" bIns="0" rtlCol="0" anchor="ctr"/>
           <a:lstStyle/>
           <a:p>
-            <a:pPr indent="0" marL="0">
+            <a:pPr marL="0" indent="0">
               <a:buNone/>
             </a:pPr>
             <a:r>
@@ -4623,7 +4892,7 @@
           </a:solidFill>
           <a:ln/>
           <a:effectLst>
-            <a:outerShdw sx="100000" sy="100000" kx="0" ky="0" algn="bl" rotWithShape="0" blurRad="76200" dist="25400" dir="8100000">
+            <a:outerShdw blurRad="76200" dist="25400" dir="8100000" algn="bl" rotWithShape="0">
               <a:srgbClr val="000000">
                 <a:alpha val="12000"/>
               </a:srgbClr>
@@ -4672,7 +4941,7 @@
           <a:bodyPr wrap="square" lIns="0" tIns="0" rIns="0" bIns="0" rtlCol="0" anchor="ctr"/>
           <a:lstStyle/>
           <a:p>
-            <a:pPr indent="0" marL="0">
+            <a:pPr marL="0" indent="0">
               <a:buNone/>
             </a:pPr>
             <a:r>
@@ -4711,7 +4980,7 @@
           <a:bodyPr wrap="square" lIns="0" tIns="0" rIns="0" bIns="0" rtlCol="0" anchor="ctr"/>
           <a:lstStyle/>
           <a:p>
-            <a:pPr indent="0" marL="0">
+            <a:pPr marL="0" indent="0">
               <a:buNone/>
             </a:pPr>
             <a:r>
@@ -4750,7 +5019,7 @@
           <a:bodyPr wrap="square" lIns="0" tIns="0" rIns="0" bIns="0" rtlCol="0" anchor="ctr"/>
           <a:lstStyle/>
           <a:p>
-            <a:pPr indent="0" marL="0">
+            <a:pPr marL="0" indent="0">
               <a:buNone/>
             </a:pPr>
             <a:r>
@@ -4787,7 +5056,7 @@
           </a:solidFill>
           <a:ln/>
           <a:effectLst>
-            <a:outerShdw sx="100000" sy="100000" kx="0" ky="0" algn="bl" rotWithShape="0" blurRad="76200" dist="25400" dir="8100000">
+            <a:outerShdw blurRad="76200" dist="25400" dir="8100000" algn="bl" rotWithShape="0">
               <a:srgbClr val="000000">
                 <a:alpha val="12000"/>
               </a:srgbClr>
@@ -4836,7 +5105,7 @@
           <a:bodyPr wrap="square" lIns="0" tIns="0" rIns="0" bIns="0" rtlCol="0" anchor="ctr"/>
           <a:lstStyle/>
           <a:p>
-            <a:pPr indent="0" marL="0">
+            <a:pPr marL="0" indent="0">
               <a:buNone/>
             </a:pPr>
             <a:r>
@@ -4875,7 +5144,7 @@
           <a:bodyPr wrap="square" lIns="0" tIns="0" rIns="0" bIns="0" rtlCol="0" anchor="ctr"/>
           <a:lstStyle/>
           <a:p>
-            <a:pPr indent="0" marL="0">
+            <a:pPr marL="0" indent="0">
               <a:buNone/>
             </a:pPr>
             <a:r>
@@ -4914,7 +5183,7 @@
           <a:bodyPr wrap="square" lIns="0" tIns="0" rIns="0" bIns="0" rtlCol="0" anchor="ctr"/>
           <a:lstStyle/>
           <a:p>
-            <a:pPr indent="0" marL="0">
+            <a:pPr marL="0" indent="0">
               <a:buNone/>
             </a:pPr>
             <a:r>
@@ -4953,7 +5222,7 @@
           <a:bodyPr wrap="square" lIns="0" tIns="0" rIns="0" bIns="0" rtlCol="0" anchor="ctr"/>
           <a:lstStyle/>
           <a:p>
-            <a:pPr indent="0" marL="0">
+            <a:pPr marL="0" indent="0">
               <a:buNone/>
             </a:pPr>
             <a:r>
@@ -4987,6 +5256,7 @@
         <a:solidFill>
           <a:srgbClr val="FFFFFF"/>
         </a:solidFill>
+        <a:effectLst/>
       </p:bgPr>
     </p:bg>
     <p:spTree>
@@ -5024,7 +5294,7 @@
           <a:bodyPr wrap="square" lIns="0" tIns="0" rIns="0" bIns="0" rtlCol="0" anchor="ctr"/>
           <a:lstStyle/>
           <a:p>
-            <a:pPr indent="0" marL="0">
+            <a:pPr marL="0" indent="0">
               <a:buNone/>
             </a:pPr>
             <a:r>
@@ -5061,7 +5331,7 @@
           </a:solidFill>
           <a:ln/>
           <a:effectLst>
-            <a:outerShdw sx="100000" sy="100000" kx="0" ky="0" algn="bl" rotWithShape="0" blurRad="76200" dist="25400" dir="8100000">
+            <a:outerShdw blurRad="76200" dist="25400" dir="8100000" algn="bl" rotWithShape="0">
               <a:srgbClr val="000000">
                 <a:alpha val="12000"/>
               </a:srgbClr>
@@ -5110,7 +5380,7 @@
           <a:bodyPr wrap="square" lIns="0" tIns="0" rIns="0" bIns="0" rtlCol="0" anchor="ctr"/>
           <a:lstStyle/>
           <a:p>
-            <a:pPr algn="ctr" indent="0" marL="0">
+            <a:pPr marL="0" indent="0" algn="ctr">
               <a:buNone/>
             </a:pPr>
             <a:r>
@@ -5149,7 +5419,7 @@
           <a:bodyPr wrap="square" lIns="0" tIns="0" rIns="0" bIns="0" rtlCol="0" anchor="ctr"/>
           <a:lstStyle/>
           <a:p>
-            <a:pPr algn="ctr" indent="0" marL="0">
+            <a:pPr marL="0" indent="0" algn="ctr">
               <a:buNone/>
             </a:pPr>
             <a:r>
@@ -5166,7 +5436,7 @@
             <a:endParaRPr lang="en-US" sz="1200" dirty="0"/>
           </a:p>
           <a:p>
-            <a:pPr algn="ctr" indent="0" marL="0">
+            <a:pPr marL="0" indent="0" algn="ctr">
               <a:buNone/>
             </a:pPr>
             <a:r>
@@ -5203,7 +5473,7 @@
           </a:solidFill>
           <a:ln/>
           <a:effectLst>
-            <a:outerShdw sx="100000" sy="100000" kx="0" ky="0" algn="bl" rotWithShape="0" blurRad="76200" dist="25400" dir="8100000">
+            <a:outerShdw blurRad="76200" dist="25400" dir="8100000" algn="bl" rotWithShape="0">
               <a:srgbClr val="000000">
                 <a:alpha val="12000"/>
               </a:srgbClr>
@@ -5252,7 +5522,7 @@
           <a:bodyPr wrap="square" lIns="0" tIns="0" rIns="0" bIns="0" rtlCol="0" anchor="ctr"/>
           <a:lstStyle/>
           <a:p>
-            <a:pPr algn="ctr" indent="0" marL="0">
+            <a:pPr marL="0" indent="0" algn="ctr">
               <a:buNone/>
             </a:pPr>
             <a:r>
@@ -5291,7 +5561,7 @@
           <a:bodyPr wrap="square" lIns="0" tIns="0" rIns="0" bIns="0" rtlCol="0" anchor="ctr"/>
           <a:lstStyle/>
           <a:p>
-            <a:pPr algn="ctr" indent="0" marL="0">
+            <a:pPr marL="0" indent="0" algn="ctr">
               <a:buNone/>
             </a:pPr>
             <a:r>
@@ -5308,7 +5578,7 @@
             <a:endParaRPr lang="en-US" sz="1200" dirty="0"/>
           </a:p>
           <a:p>
-            <a:pPr algn="ctr" indent="0" marL="0">
+            <a:pPr marL="0" indent="0" algn="ctr">
               <a:buNone/>
             </a:pPr>
             <a:r>
@@ -5345,7 +5615,7 @@
           </a:solidFill>
           <a:ln/>
           <a:effectLst>
-            <a:outerShdw sx="100000" sy="100000" kx="0" ky="0" algn="bl" rotWithShape="0" blurRad="76200" dist="25400" dir="8100000">
+            <a:outerShdw blurRad="76200" dist="25400" dir="8100000" algn="bl" rotWithShape="0">
               <a:srgbClr val="000000">
                 <a:alpha val="12000"/>
               </a:srgbClr>
@@ -5394,7 +5664,7 @@
           <a:bodyPr wrap="square" lIns="0" tIns="0" rIns="0" bIns="0" rtlCol="0" anchor="ctr"/>
           <a:lstStyle/>
           <a:p>
-            <a:pPr algn="ctr" indent="0" marL="0">
+            <a:pPr marL="0" indent="0" algn="ctr">
               <a:buNone/>
             </a:pPr>
             <a:r>
@@ -5433,7 +5703,7 @@
           <a:bodyPr wrap="square" lIns="0" tIns="0" rIns="0" bIns="0" rtlCol="0" anchor="ctr"/>
           <a:lstStyle/>
           <a:p>
-            <a:pPr algn="ctr" indent="0" marL="0">
+            <a:pPr marL="0" indent="0" algn="ctr">
               <a:buNone/>
             </a:pPr>
             <a:r>
@@ -5450,7 +5720,7 @@
             <a:endParaRPr lang="en-US" sz="1200" dirty="0"/>
           </a:p>
           <a:p>
-            <a:pPr algn="ctr" indent="0" marL="0">
+            <a:pPr marL="0" indent="0" algn="ctr">
               <a:buNone/>
             </a:pPr>
             <a:r>
@@ -5487,7 +5757,7 @@
           </a:solidFill>
           <a:ln/>
           <a:effectLst>
-            <a:outerShdw sx="100000" sy="100000" kx="0" ky="0" algn="bl" rotWithShape="0" blurRad="76200" dist="25400" dir="8100000">
+            <a:outerShdw blurRad="76200" dist="25400" dir="8100000" algn="bl" rotWithShape="0">
               <a:srgbClr val="000000">
                 <a:alpha val="12000"/>
               </a:srgbClr>
@@ -5536,7 +5806,7 @@
           <a:bodyPr wrap="square" lIns="0" tIns="0" rIns="0" bIns="0" rtlCol="0" anchor="ctr"/>
           <a:lstStyle/>
           <a:p>
-            <a:pPr algn="ctr" indent="0" marL="0">
+            <a:pPr marL="0" indent="0" algn="ctr">
               <a:buNone/>
             </a:pPr>
             <a:r>
@@ -5575,7 +5845,7 @@
           <a:bodyPr wrap="square" lIns="0" tIns="0" rIns="0" bIns="0" rtlCol="0" anchor="ctr"/>
           <a:lstStyle/>
           <a:p>
-            <a:pPr algn="ctr" indent="0" marL="0">
+            <a:pPr marL="0" indent="0" algn="ctr">
               <a:buNone/>
             </a:pPr>
             <a:r>
@@ -5592,7 +5862,7 @@
             <a:endParaRPr lang="en-US" sz="1200" dirty="0"/>
           </a:p>
           <a:p>
-            <a:pPr algn="ctr" indent="0" marL="0">
+            <a:pPr marL="0" indent="0" algn="ctr">
               <a:buNone/>
             </a:pPr>
             <a:r>
@@ -5631,7 +5901,7 @@
           <a:bodyPr wrap="square" lIns="0" tIns="0" rIns="0" bIns="0" rtlCol="0" anchor="ctr"/>
           <a:lstStyle/>
           <a:p>
-            <a:pPr indent="0" marL="0">
+            <a:pPr marL="0" indent="0">
               <a:buNone/>
             </a:pPr>
             <a:r>
@@ -5670,7 +5940,7 @@
           <a:bodyPr wrap="square" rtlCol="0" anchor="ctr"/>
           <a:lstStyle/>
           <a:p>
-            <a:pPr indent="0" marL="0">
+            <a:pPr marL="0" indent="0">
               <a:spcAft>
                 <a:spcPts val="800"/>
               </a:spcAft>
@@ -5687,13 +5957,38 @@
               </a:rPr>
               <a:t>Intervention Planner: </a:t>
             </a:r>
-            <a:pPr indent="0" marL="0">
+            <a:r>
+              <a:rPr lang="en-US" sz="1400" dirty="0">
+                <a:solidFill>
+                  <a:srgbClr val="1B2A4A"/>
+                </a:solidFill>
+                <a:latin typeface="Calibri" pitchFamily="34" charset="0"/>
+                <a:ea typeface="Calibri" pitchFamily="34" charset="-122"/>
+                <a:cs typeface="Calibri" pitchFamily="34" charset="-120"/>
+              </a:rPr>
+              <a:t>Outreaching top 50 patients → est. 96 fewer ED visits/yr</a:t>
+            </a:r>
+            <a:endParaRPr lang="en-US" sz="1400" dirty="0"/>
+          </a:p>
+          <a:p>
+            <a:pPr marL="0" indent="0">
               <a:spcAft>
                 <a:spcPts val="800"/>
               </a:spcAft>
               <a:buNone/>
             </a:pPr>
             <a:r>
+              <a:rPr lang="en-US" sz="1400" b="1" dirty="0">
+                <a:solidFill>
+                  <a:srgbClr val="1B2A4A"/>
+                </a:solidFill>
+                <a:latin typeface="Calibri" pitchFamily="34" charset="0"/>
+                <a:ea typeface="Calibri" pitchFamily="34" charset="-122"/>
+                <a:cs typeface="Calibri" pitchFamily="34" charset="-120"/>
+              </a:rPr>
+              <a:t>Scenario Simulator: </a:t>
+            </a:r>
+            <a:r>
               <a:rPr lang="en-US" sz="1400" dirty="0">
                 <a:solidFill>
                   <a:srgbClr val="1B2A4A"/>
@@ -5702,12 +5997,12 @@
                 <a:ea typeface="Calibri" pitchFamily="34" charset="-122"/>
                 <a:cs typeface="Calibri" pitchFamily="34" charset="-120"/>
               </a:rPr>
-              <a:t>Outreaching top 50 patients → est. 96 fewer ED visits/yr</a:t>
+              <a:t>5pp GP attachment improvement → 547 patients shift to lower-urgency tiers</a:t>
             </a:r>
             <a:endParaRPr lang="en-US" sz="1400" dirty="0"/>
           </a:p>
           <a:p>
-            <a:pPr indent="0" marL="0">
+            <a:pPr marL="0" indent="0">
               <a:spcAft>
                 <a:spcPts val="800"/>
               </a:spcAft>
@@ -5722,51 +6017,8 @@
                 <a:ea typeface="Calibri" pitchFamily="34" charset="-122"/>
                 <a:cs typeface="Calibri" pitchFamily="34" charset="-120"/>
               </a:rPr>
-              <a:t>Scenario Simulator: </a:t>
-            </a:r>
-            <a:pPr indent="0" marL="0">
-              <a:spcAft>
-                <a:spcPts val="800"/>
-              </a:spcAft>
-              <a:buNone/>
-            </a:pPr>
-            <a:r>
-              <a:rPr lang="en-US" sz="1400" dirty="0">
-                <a:solidFill>
-                  <a:srgbClr val="1B2A4A"/>
-                </a:solidFill>
-                <a:latin typeface="Calibri" pitchFamily="34" charset="0"/>
-                <a:ea typeface="Calibri" pitchFamily="34" charset="-122"/>
-                <a:cs typeface="Calibri" pitchFamily="34" charset="-120"/>
-              </a:rPr>
-              <a:t>5pp GP attachment improvement → 547 patients shift to lower-urgency tiers</a:t>
-            </a:r>
-            <a:endParaRPr lang="en-US" sz="1400" dirty="0"/>
-          </a:p>
-          <a:p>
-            <a:pPr indent="0" marL="0">
-              <a:spcAft>
-                <a:spcPts val="800"/>
-              </a:spcAft>
-              <a:buNone/>
-            </a:pPr>
-            <a:r>
-              <a:rPr lang="en-US" sz="1400" b="1" dirty="0">
-                <a:solidFill>
-                  <a:srgbClr val="1B2A4A"/>
-                </a:solidFill>
-                <a:latin typeface="Calibri" pitchFamily="34" charset="0"/>
-                <a:ea typeface="Calibri" pitchFamily="34" charset="-122"/>
-                <a:cs typeface="Calibri" pitchFamily="34" charset="-120"/>
-              </a:rPr>
               <a:t>"Why Now?" module: </a:t>
             </a:r>
-            <a:pPr indent="0" marL="0">
-              <a:spcAft>
-                <a:spcPts val="800"/>
-              </a:spcAft>
-              <a:buNone/>
-            </a:pPr>
             <a:r>
               <a:rPr lang="en-US" sz="1400" dirty="0">
                 <a:solidFill>
@@ -5803,7 +6055,7 @@
           <a:bodyPr wrap="square" lIns="0" tIns="0" rIns="0" bIns="0" rtlCol="0" anchor="ctr"/>
           <a:lstStyle/>
           <a:p>
-            <a:pPr indent="0" marL="0">
+            <a:pPr marL="0" indent="0">
               <a:buNone/>
             </a:pPr>
             <a:r>
@@ -5837,6 +6089,7 @@
         <a:solidFill>
           <a:srgbClr val="F0F4F8"/>
         </a:solidFill>
+        <a:effectLst/>
       </p:bgPr>
     </p:bg>
     <p:spTree>
@@ -5874,7 +6127,7 @@
           <a:bodyPr wrap="square" lIns="0" tIns="0" rIns="0" bIns="0" rtlCol="0" anchor="ctr"/>
           <a:lstStyle/>
           <a:p>
-            <a:pPr indent="0" marL="0">
+            <a:pPr marL="0" indent="0">
               <a:buNone/>
             </a:pPr>
             <a:r>
@@ -5913,7 +6166,7 @@
           <a:bodyPr wrap="square" lIns="0" tIns="0" rIns="0" bIns="0" rtlCol="0" anchor="ctr"/>
           <a:lstStyle/>
           <a:p>
-            <a:pPr indent="0" marL="0">
+            <a:pPr marL="0" indent="0">
               <a:buNone/>
             </a:pPr>
             <a:r>
@@ -5952,7 +6205,7 @@
           <a:bodyPr wrap="square" lIns="0" tIns="0" rIns="0" bIns="0" rtlCol="0" anchor="ctr"/>
           <a:lstStyle/>
           <a:p>
-            <a:pPr indent="0" marL="0">
+            <a:pPr marL="0" indent="0">
               <a:buNone/>
             </a:pPr>
             <a:r>
@@ -6139,7 +6392,7 @@
           <a:bodyPr wrap="square" lIns="0" tIns="0" rIns="0" bIns="0" rtlCol="0" anchor="ctr"/>
           <a:lstStyle/>
           <a:p>
-            <a:pPr indent="0" marL="0">
+            <a:pPr marL="0" indent="0">
               <a:buNone/>
             </a:pPr>
             <a:r>
@@ -6325,7 +6578,7 @@
           <a:bodyPr wrap="square" lIns="0" tIns="0" rIns="0" bIns="0" rtlCol="0" anchor="ctr"/>
           <a:lstStyle/>
           <a:p>
-            <a:pPr algn="ctr" indent="0" marL="0">
+            <a:pPr marL="0" indent="0" algn="ctr">
               <a:buNone/>
             </a:pPr>
             <a:r>
@@ -6359,6 +6612,7 @@
         <a:solidFill>
           <a:srgbClr val="0B2545"/>
         </a:solidFill>
+        <a:effectLst/>
       </p:bgPr>
     </p:bg>
     <p:spTree>
@@ -6416,7 +6670,7 @@
           <a:bodyPr wrap="square" lIns="0" tIns="0" rIns="0" bIns="0" rtlCol="0" anchor="ctr"/>
           <a:lstStyle/>
           <a:p>
-            <a:pPr indent="0" marL="0">
+            <a:pPr marL="0" indent="0">
               <a:buNone/>
             </a:pPr>
             <a:r>
@@ -6478,7 +6732,7 @@
           <a:bodyPr wrap="square" lIns="0" tIns="0" rIns="0" bIns="0" rtlCol="0" anchor="ctr"/>
           <a:lstStyle/>
           <a:p>
-            <a:pPr indent="0" marL="0">
+            <a:pPr marL="0" indent="0">
               <a:spcAft>
                 <a:spcPts val="400"/>
               </a:spcAft>
@@ -6498,7 +6752,7 @@
             <a:endParaRPr lang="en-US" sz="1800" dirty="0"/>
           </a:p>
           <a:p>
-            <a:pPr indent="0" marL="0">
+            <a:pPr marL="0" indent="0">
               <a:spcAft>
                 <a:spcPts val="400"/>
               </a:spcAft>
@@ -6512,7 +6766,7 @@
                 <a:latin typeface="Calibri" pitchFamily="34" charset="0"/>
                 <a:ea typeface="Calibri" pitchFamily="34" charset="-122"/>
                 <a:cs typeface="Calibri" pitchFamily="34" charset="-120"/>
-                <a:hlinkClick r:id="rId1" invalidUrl="" action="" tgtFrame="" tooltip="" history="1" highlightClick="0" endSnd="0">
+                <a:hlinkClick r:id="rId3">
                   <a:extLst>
                     <a:ext uri="{A12FA001-AC4F-418D-AE19-62706E023703}">
                       <ahyp:hlinkClr xmlns:ahyp="http://schemas.microsoft.com/office/drawing/2018/hyperlinkcolor" val="tx"/>
@@ -6525,7 +6779,7 @@
             <a:endParaRPr lang="en-US" sz="1800" dirty="0"/>
           </a:p>
           <a:p>
-            <a:pPr indent="0" marL="0">
+            <a:pPr marL="0" indent="0">
               <a:spcAft>
                 <a:spcPts val="400"/>
               </a:spcAft>
@@ -6534,7 +6788,7 @@
             <a:endParaRPr lang="en-US" sz="1800" dirty="0"/>
           </a:p>
           <a:p>
-            <a:pPr indent="0" marL="0">
+            <a:pPr marL="0" indent="0">
               <a:spcAft>
                 <a:spcPts val="400"/>
               </a:spcAft>
@@ -6554,7 +6808,7 @@
             <a:endParaRPr lang="en-US" sz="1800" dirty="0"/>
           </a:p>
           <a:p>
-            <a:pPr indent="0" marL="0">
+            <a:pPr marL="0" indent="0">
               <a:spcAft>
                 <a:spcPts val="400"/>
               </a:spcAft>
@@ -6568,7 +6822,7 @@
                 <a:latin typeface="Calibri" pitchFamily="34" charset="0"/>
                 <a:ea typeface="Calibri" pitchFamily="34" charset="-122"/>
                 <a:cs typeface="Calibri" pitchFamily="34" charset="-120"/>
-                <a:hlinkClick r:id="rId2" invalidUrl="" action="" tgtFrame="" tooltip="" history="1" highlightClick="0" endSnd="0">
+                <a:hlinkClick r:id="rId4">
                   <a:extLst>
                     <a:ext uri="{A12FA001-AC4F-418D-AE19-62706E023703}">
                       <ahyp:hlinkClr xmlns:ahyp="http://schemas.microsoft.com/office/drawing/2018/hyperlinkcolor" val="tx"/>
@@ -6603,7 +6857,7 @@
           <a:bodyPr wrap="square" lIns="0" tIns="0" rIns="0" bIns="0" rtlCol="0" anchor="ctr"/>
           <a:lstStyle/>
           <a:p>
-            <a:pPr indent="0" marL="0">
+            <a:pPr marL="0" indent="0">
               <a:buNone/>
             </a:pPr>
             <a:r>
@@ -6922,4 +7176,299 @@
     </a:ext>
   </a:extLst>
 </a:theme>
+</file>
+
+<file path=ppt/theme/theme2.xml><?xml version="1.0" encoding="utf-8"?>
+<a:theme xmlns:a="http://schemas.openxmlformats.org/drawingml/2006/main" name="Office 主题​​">
+  <a:themeElements>
+    <a:clrScheme name="Office">
+      <a:dk1>
+        <a:sysClr val="windowText" lastClr="000000"/>
+      </a:dk1>
+      <a:lt1>
+        <a:sysClr val="window" lastClr="FFFFFF"/>
+      </a:lt1>
+      <a:dk2>
+        <a:srgbClr val="44546A"/>
+      </a:dk2>
+      <a:lt2>
+        <a:srgbClr val="E7E6E6"/>
+      </a:lt2>
+      <a:accent1>
+        <a:srgbClr val="4472C4"/>
+      </a:accent1>
+      <a:accent2>
+        <a:srgbClr val="ED7D31"/>
+      </a:accent2>
+      <a:accent3>
+        <a:srgbClr val="A5A5A5"/>
+      </a:accent3>
+      <a:accent4>
+        <a:srgbClr val="FFC000"/>
+      </a:accent4>
+      <a:accent5>
+        <a:srgbClr val="5B9BD5"/>
+      </a:accent5>
+      <a:accent6>
+        <a:srgbClr val="70AD47"/>
+      </a:accent6>
+      <a:hlink>
+        <a:srgbClr val="0563C1"/>
+      </a:hlink>
+      <a:folHlink>
+        <a:srgbClr val="954F72"/>
+      </a:folHlink>
+    </a:clrScheme>
+    <a:fontScheme name="Office">
+      <a:majorFont>
+        <a:latin typeface="等线 Light" panose="020F0302020204030204"/>
+        <a:ea typeface=""/>
+        <a:cs typeface=""/>
+        <a:font script="Jpan" typeface="游ゴシック Light"/>
+        <a:font script="Hang" typeface="맑은 고딕"/>
+        <a:font script="Hans" typeface="等线 Light"/>
+        <a:font script="Hant" typeface="新細明體"/>
+        <a:font script="Arab" typeface="Times New Roman"/>
+        <a:font script="Hebr" typeface="Times New Roman"/>
+        <a:font script="Thai" typeface="Angsana New"/>
+        <a:font script="Ethi" typeface="Nyala"/>
+        <a:font script="Beng" typeface="Vrinda"/>
+        <a:font script="Gujr" typeface="Shruti"/>
+        <a:font script="Khmr" typeface="MoolBoran"/>
+        <a:font script="Knda" typeface="Tunga"/>
+        <a:font script="Guru" typeface="Raavi"/>
+        <a:font script="Cans" typeface="Euphemia"/>
+        <a:font script="Cher" typeface="Plantagenet Cherokee"/>
+        <a:font script="Yiii" typeface="Microsoft Yi Baiti"/>
+        <a:font script="Tibt" typeface="Microsoft Himalaya"/>
+        <a:font script="Thaa" typeface="MV Boli"/>
+        <a:font script="Deva" typeface="Mangal"/>
+        <a:font script="Telu" typeface="Gautami"/>
+        <a:font script="Taml" typeface="Latha"/>
+        <a:font script="Syrc" typeface="Estrangelo Edessa"/>
+        <a:font script="Orya" typeface="Kalinga"/>
+        <a:font script="Mlym" typeface="Kartika"/>
+        <a:font script="Laoo" typeface="DokChampa"/>
+        <a:font script="Sinh" typeface="Iskoola Pota"/>
+        <a:font script="Mong" typeface="Mongolian Baiti"/>
+        <a:font script="Viet" typeface="Times New Roman"/>
+        <a:font script="Uigh" typeface="Microsoft Uighur"/>
+        <a:font script="Geor" typeface="Sylfaen"/>
+        <a:font script="Armn" typeface="Arial"/>
+        <a:font script="Bugi" typeface="Leelawadee UI"/>
+        <a:font script="Bopo" typeface="Microsoft JhengHei"/>
+        <a:font script="Java" typeface="Javanese Text"/>
+        <a:font script="Lisu" typeface="Segoe UI"/>
+        <a:font script="Mymr" typeface="Myanmar Text"/>
+        <a:font script="Nkoo" typeface="Ebrima"/>
+        <a:font script="Olck" typeface="Nirmala UI"/>
+        <a:font script="Osma" typeface="Ebrima"/>
+        <a:font script="Phag" typeface="Phagspa"/>
+        <a:font script="Syrn" typeface="Estrangelo Edessa"/>
+        <a:font script="Syrj" typeface="Estrangelo Edessa"/>
+        <a:font script="Syre" typeface="Estrangelo Edessa"/>
+        <a:font script="Sora" typeface="Nirmala UI"/>
+        <a:font script="Tale" typeface="Microsoft Tai Le"/>
+        <a:font script="Talu" typeface="Microsoft New Tai Lue"/>
+        <a:font script="Tfng" typeface="Ebrima"/>
+      </a:majorFont>
+      <a:minorFont>
+        <a:latin typeface="等线" panose="020F0502020204030204"/>
+        <a:ea typeface=""/>
+        <a:cs typeface=""/>
+        <a:font script="Jpan" typeface="游ゴシック"/>
+        <a:font script="Hang" typeface="맑은 고딕"/>
+        <a:font script="Hans" typeface="等线"/>
+        <a:font script="Hant" typeface="新細明體"/>
+        <a:font script="Arab" typeface="Arial"/>
+        <a:font script="Hebr" typeface="Arial"/>
+        <a:font script="Thai" typeface="Cordia New"/>
+        <a:font script="Ethi" typeface="Nyala"/>
+        <a:font script="Beng" typeface="Vrinda"/>
+        <a:font script="Gujr" typeface="Shruti"/>
+        <a:font script="Khmr" typeface="DaunPenh"/>
+        <a:font script="Knda" typeface="Tunga"/>
+        <a:font script="Guru" typeface="Raavi"/>
+        <a:font script="Cans" typeface="Euphemia"/>
+        <a:font script="Cher" typeface="Plantagenet Cherokee"/>
+        <a:font script="Yiii" typeface="Microsoft Yi Baiti"/>
+        <a:font script="Tibt" typeface="Microsoft Himalaya"/>
+        <a:font script="Thaa" typeface="MV Boli"/>
+        <a:font script="Deva" typeface="Mangal"/>
+        <a:font script="Telu" typeface="Gautami"/>
+        <a:font script="Taml" typeface="Latha"/>
+        <a:font script="Syrc" typeface="Estrangelo Edessa"/>
+        <a:font script="Orya" typeface="Kalinga"/>
+        <a:font script="Mlym" typeface="Kartika"/>
+        <a:font script="Laoo" typeface="DokChampa"/>
+        <a:font script="Sinh" typeface="Iskoola Pota"/>
+        <a:font script="Mong" typeface="Mongolian Baiti"/>
+        <a:font script="Viet" typeface="Arial"/>
+        <a:font script="Uigh" typeface="Microsoft Uighur"/>
+        <a:font script="Geor" typeface="Sylfaen"/>
+        <a:font script="Armn" typeface="Arial"/>
+        <a:font script="Bugi" typeface="Leelawadee UI"/>
+        <a:font script="Bopo" typeface="Microsoft JhengHei"/>
+        <a:font script="Java" typeface="Javanese Text"/>
+        <a:font script="Lisu" typeface="Segoe UI"/>
+        <a:font script="Mymr" typeface="Myanmar Text"/>
+        <a:font script="Nkoo" typeface="Ebrima"/>
+        <a:font script="Olck" typeface="Nirmala UI"/>
+        <a:font script="Osma" typeface="Ebrima"/>
+        <a:font script="Phag" typeface="Phagspa"/>
+        <a:font script="Syrn" typeface="Estrangelo Edessa"/>
+        <a:font script="Syrj" typeface="Estrangelo Edessa"/>
+        <a:font script="Syre" typeface="Estrangelo Edessa"/>
+        <a:font script="Sora" typeface="Nirmala UI"/>
+        <a:font script="Tale" typeface="Microsoft Tai Le"/>
+        <a:font script="Talu" typeface="Microsoft New Tai Lue"/>
+        <a:font script="Tfng" typeface="Ebrima"/>
+      </a:minorFont>
+    </a:fontScheme>
+    <a:fmtScheme name="Office">
+      <a:fillStyleLst>
+        <a:solidFill>
+          <a:schemeClr val="phClr"/>
+        </a:solidFill>
+        <a:gradFill rotWithShape="1">
+          <a:gsLst>
+            <a:gs pos="0">
+              <a:schemeClr val="phClr">
+                <a:lumMod val="110000"/>
+                <a:satMod val="105000"/>
+                <a:tint val="67000"/>
+              </a:schemeClr>
+            </a:gs>
+            <a:gs pos="50000">
+              <a:schemeClr val="phClr">
+                <a:lumMod val="105000"/>
+                <a:satMod val="103000"/>
+                <a:tint val="73000"/>
+              </a:schemeClr>
+            </a:gs>
+            <a:gs pos="100000">
+              <a:schemeClr val="phClr">
+                <a:lumMod val="105000"/>
+                <a:satMod val="109000"/>
+                <a:tint val="81000"/>
+              </a:schemeClr>
+            </a:gs>
+          </a:gsLst>
+          <a:lin ang="5400000" scaled="0"/>
+        </a:gradFill>
+        <a:gradFill rotWithShape="1">
+          <a:gsLst>
+            <a:gs pos="0">
+              <a:schemeClr val="phClr">
+                <a:satMod val="103000"/>
+                <a:lumMod val="102000"/>
+                <a:tint val="94000"/>
+              </a:schemeClr>
+            </a:gs>
+            <a:gs pos="50000">
+              <a:schemeClr val="phClr">
+                <a:satMod val="110000"/>
+                <a:lumMod val="100000"/>
+                <a:shade val="100000"/>
+              </a:schemeClr>
+            </a:gs>
+            <a:gs pos="100000">
+              <a:schemeClr val="phClr">
+                <a:lumMod val="99000"/>
+                <a:satMod val="120000"/>
+                <a:shade val="78000"/>
+              </a:schemeClr>
+            </a:gs>
+          </a:gsLst>
+          <a:lin ang="5400000" scaled="0"/>
+        </a:gradFill>
+      </a:fillStyleLst>
+      <a:lnStyleLst>
+        <a:ln w="6350" cap="flat" cmpd="sng" algn="ctr">
+          <a:solidFill>
+            <a:schemeClr val="phClr"/>
+          </a:solidFill>
+          <a:prstDash val="solid"/>
+          <a:miter lim="800000"/>
+        </a:ln>
+        <a:ln w="12700" cap="flat" cmpd="sng" algn="ctr">
+          <a:solidFill>
+            <a:schemeClr val="phClr"/>
+          </a:solidFill>
+          <a:prstDash val="solid"/>
+          <a:miter lim="800000"/>
+        </a:ln>
+        <a:ln w="19050" cap="flat" cmpd="sng" algn="ctr">
+          <a:solidFill>
+            <a:schemeClr val="phClr"/>
+          </a:solidFill>
+          <a:prstDash val="solid"/>
+          <a:miter lim="800000"/>
+        </a:ln>
+      </a:lnStyleLst>
+      <a:effectStyleLst>
+        <a:effectStyle>
+          <a:effectLst/>
+        </a:effectStyle>
+        <a:effectStyle>
+          <a:effectLst/>
+        </a:effectStyle>
+        <a:effectStyle>
+          <a:effectLst>
+            <a:outerShdw blurRad="57150" dist="19050" dir="5400000" algn="ctr" rotWithShape="0">
+              <a:srgbClr val="000000">
+                <a:alpha val="63000"/>
+              </a:srgbClr>
+            </a:outerShdw>
+          </a:effectLst>
+        </a:effectStyle>
+      </a:effectStyleLst>
+      <a:bgFillStyleLst>
+        <a:solidFill>
+          <a:schemeClr val="phClr"/>
+        </a:solidFill>
+        <a:solidFill>
+          <a:schemeClr val="phClr">
+            <a:tint val="95000"/>
+            <a:satMod val="170000"/>
+          </a:schemeClr>
+        </a:solidFill>
+        <a:gradFill rotWithShape="1">
+          <a:gsLst>
+            <a:gs pos="0">
+              <a:schemeClr val="phClr">
+                <a:tint val="93000"/>
+                <a:satMod val="150000"/>
+                <a:shade val="98000"/>
+                <a:lumMod val="102000"/>
+              </a:schemeClr>
+            </a:gs>
+            <a:gs pos="50000">
+              <a:schemeClr val="phClr">
+                <a:tint val="98000"/>
+                <a:satMod val="130000"/>
+                <a:shade val="90000"/>
+                <a:lumMod val="103000"/>
+              </a:schemeClr>
+            </a:gs>
+            <a:gs pos="100000">
+              <a:schemeClr val="phClr">
+                <a:shade val="63000"/>
+                <a:satMod val="120000"/>
+              </a:schemeClr>
+            </a:gs>
+          </a:gsLst>
+          <a:lin ang="5400000" scaled="0"/>
+        </a:gradFill>
+      </a:bgFillStyleLst>
+    </a:fmtScheme>
+  </a:themeElements>
+  <a:objectDefaults/>
+  <a:extraClrSchemeLst/>
+  <a:extLst>
+    <a:ext uri="{05A4C25C-085E-4340-85A3-A5531E510DB2}">
+      <thm15:themeFamily xmlns:thm15="http://schemas.microsoft.com/office/thememl/2012/main" name="Office Theme" id="{62F939B6-93AF-4DB8-9C6B-D6C7DFDC589F}" vid="{4A3C46E8-61CC-4603-A589-7422A47A8E4A}"/>
+    </a:ext>
+  </a:extLst>
+</a:theme>
 </file>
</xml_diff>